<commit_message>
Add an embedded two-cell collision video slide to the mid-term deck
New slide 8, "Already underway: a first two-cell experiment", between
the Version 4 crawl slide and the take-homes. Embeds the 3-second
glancing-collision video from the cursor/two-cell-crawling-7d60
branch (python-pptx add_movie, with a poster frame at the moment of
contact) alongside the one new free-energy term that couples the two
cells. Deck is now 10 slides; footer numbering and the title slide's
slide count updated throughout.

Co-authored-by: ariaydrouch <ariaydrouch@users.noreply.github.com>
</commit_message>
<xml_diff>
--- a/presentation/PYD411_midsem_presentation.pptx
+++ b/presentation/PYD411_midsem_presentation.pptx
@@ -14,6 +14,7 @@
     <p:sldId id="262" r:id="rId14"/>
     <p:sldId id="263" r:id="rId15"/>
     <p:sldId id="264" r:id="rId16"/>
+    <p:sldId id="265" r:id="rId17"/>
   </p:sldIdLst>
   <p:sldSz cx="12191695" cy="6858000" type="screen4x3"/>
   <p:notesSz cx="6858000" cy="9144000"/>
@@ -535,6 +536,76 @@
 </p:notes>
 </file>
 
+<file path=ppt/notesSlides/notesSlide10.xml><?xml version="1.0" encoding="utf-8"?>
+<p:notes xmlns:a="http://schemas.openxmlformats.org/drawingml/2006/main" xmlns:p="http://schemas.openxmlformats.org/presentationml/2006/main" xmlns:r="http://schemas.openxmlformats.org/officeDocument/2006/relationships">
+  <p:cSld>
+    <p:spTree>
+      <p:nvGrpSpPr>
+        <p:cNvPr id="1" name=""/>
+        <p:cNvGrpSpPr/>
+        <p:nvPr/>
+      </p:nvGrpSpPr>
+      <p:grpSpPr>
+        <a:xfrm>
+          <a:off x="0" y="0"/>
+          <a:ext cx="0" cy="0"/>
+          <a:chOff x="0" y="0"/>
+          <a:chExt cx="0" cy="0"/>
+        </a:xfrm>
+      </p:grpSpPr>
+      <p:sp>
+        <p:nvSpPr>
+          <p:cNvPr id="2" name="Slide Image Placeholder 1"/>
+          <p:cNvSpPr>
+            <a:spLocks noGrp="1"/>
+          </p:cNvSpPr>
+          <p:nvPr>
+            <p:ph type="sldImg" idx="2"/>
+          </p:nvPr>
+        </p:nvSpPr>
+        <p:spPr/>
+      </p:sp>
+      <p:sp>
+        <p:nvSpPr>
+          <p:cNvPr id="3" name="Notes Placeholder 2"/>
+          <p:cNvSpPr>
+            <a:spLocks noGrp="1"/>
+          </p:cNvSpPr>
+          <p:nvPr>
+            <p:ph type="body" idx="3" sz="quarter"/>
+          </p:nvPr>
+        </p:nvSpPr>
+        <p:spPr/>
+        <p:txBody>
+          <a:bodyPr/>
+          <a:lstStyle/>
+          <a:p>
+            <a:r>
+              <a:t>The immediate next step is two-cell interaction, followed by collisions and dynamic polarity. The ultimate goal is to study collective behaviour using the local formulation.</a:t>
+            </a:r>
+          </a:p>
+        </p:txBody>
+      </p:sp>
+      <p:sp>
+        <p:nvSpPr>
+          <p:cNvPr id="4" name="Slide Number Placeholder 3"/>
+          <p:cNvSpPr>
+            <a:spLocks noGrp="1"/>
+          </p:cNvSpPr>
+          <p:nvPr>
+            <p:ph type="sldNum" idx="5" sz="quarter"/>
+          </p:nvPr>
+        </p:nvSpPr>
+        <p:spPr/>
+      </p:sp>
+    </p:spTree>
+  </p:cSld>
+  <p:clrMapOvr>
+    <a:masterClrMapping/>
+  </p:clrMapOvr>
+</p:notes>
+</file>
+
 <file path=ppt/notesSlides/notesSlide2.xml><?xml version="1.0" encoding="utf-8"?>
 <p:notes xmlns:a="http://schemas.openxmlformats.org/drawingml/2006/main" xmlns:p="http://schemas.openxmlformats.org/presentationml/2006/main" xmlns:r="http://schemas.openxmlformats.org/officeDocument/2006/relationships">
   <p:cSld>
@@ -1000,7 +1071,7 @@
           <a:lstStyle/>
           <a:p>
             <a:r>
-              <a:t>The main outcome is not simply a faster simulation. We identified which mechanisms control the observed behaviour and reduced the model while retaining the essential single-cell crawling dynamics.</a:t>
+              <a:t>This is not a finished result, it is evidence that the extension to many cells works mechanically. Two cells, each running the exact single-cell Version 4 equations, coupled by one new steric repulsion term in the free energy. A glancing collision shows a clean approach, contact, and scatter, with no merging and no global solve required. Head-on collisions are harder and are flagged as the next thing to get right.</a:t>
             </a:r>
           </a:p>
         </p:txBody>
@@ -1070,7 +1141,7 @@
           <a:lstStyle/>
           <a:p>
             <a:r>
-              <a:t>The immediate next step is two-cell interaction, followed by collisions and dynamic polarity. The ultimate goal is to study collective behaviour using the local formulation.</a:t>
+              <a:t>The main outcome is not simply a faster simulation. We identified which mechanisms control the observed behaviour and reduced the model while retaining the essential single-cell crawling dynamics.</a:t>
             </a:r>
           </a:p>
         </p:txBody>
@@ -4490,7 +4561,988 @@
                 </a:solidFill>
                 <a:latin typeface="Calibri"/>
               </a:rPr>
-              <a:t>8 minutes  ·  9 slides  ·  2 minutes for discussion</a:t>
+              <a:t>8 minutes  ·  10 slides  ·  2 minutes for discussion</a:t>
+            </a:r>
+          </a:p>
+        </p:txBody>
+      </p:sp>
+    </p:spTree>
+  </p:cSld>
+  <p:clrMapOvr>
+    <a:masterClrMapping/>
+  </p:clrMapOvr>
+</p:sld>
+</file>
+
+<file path=ppt/slides/slide10.xml><?xml version="1.0" encoding="utf-8"?>
+<p:sld xmlns:a="http://schemas.openxmlformats.org/drawingml/2006/main" xmlns:p="http://schemas.openxmlformats.org/presentationml/2006/main" xmlns:r="http://schemas.openxmlformats.org/officeDocument/2006/relationships">
+  <p:cSld>
+    <p:spTree>
+      <p:nvGrpSpPr>
+        <p:cNvPr id="1" name=""/>
+        <p:cNvGrpSpPr/>
+        <p:nvPr/>
+      </p:nvGrpSpPr>
+      <p:grpSpPr/>
+      <p:sp>
+        <p:nvSpPr>
+          <p:cNvPr id="2" name="Rectangle 1"/>
+          <p:cNvSpPr/>
+          <p:nvPr/>
+        </p:nvSpPr>
+        <p:spPr>
+          <a:xfrm>
+            <a:off x="0" y="0"/>
+            <a:ext cx="12191695" cy="6858000"/>
+          </a:xfrm>
+          <a:prstGeom prst="rect">
+            <a:avLst/>
+          </a:prstGeom>
+          <a:solidFill>
+            <a:srgbClr val="FFFFFF"/>
+          </a:solidFill>
+          <a:ln>
+            <a:noFill/>
+          </a:ln>
+          <a:effectLst/>
+        </p:spPr>
+        <p:style>
+          <a:lnRef idx="1">
+            <a:schemeClr val="accent1"/>
+          </a:lnRef>
+          <a:fillRef idx="3">
+            <a:schemeClr val="accent1"/>
+          </a:fillRef>
+          <a:effectRef idx="2">
+            <a:schemeClr val="accent1"/>
+          </a:effectRef>
+          <a:fontRef idx="minor">
+            <a:schemeClr val="lt1"/>
+          </a:fontRef>
+        </p:style>
+        <p:txBody>
+          <a:bodyPr rtlCol="0" anchor="ctr"/>
+          <a:lstStyle/>
+          <a:p>
+            <a:pPr algn="ctr"/>
+          </a:p>
+        </p:txBody>
+      </p:sp>
+      <p:sp>
+        <p:nvSpPr>
+          <p:cNvPr id="3" name="Rectangle 2"/>
+          <p:cNvSpPr/>
+          <p:nvPr/>
+        </p:nvSpPr>
+        <p:spPr>
+          <a:xfrm>
+            <a:off x="0" y="0"/>
+            <a:ext cx="12191695" cy="786384"/>
+          </a:xfrm>
+          <a:prstGeom prst="rect">
+            <a:avLst/>
+          </a:prstGeom>
+          <a:solidFill>
+            <a:srgbClr val="0B3D5C"/>
+          </a:solidFill>
+          <a:ln>
+            <a:noFill/>
+          </a:ln>
+          <a:effectLst/>
+        </p:spPr>
+        <p:style>
+          <a:lnRef idx="1">
+            <a:schemeClr val="accent1"/>
+          </a:lnRef>
+          <a:fillRef idx="3">
+            <a:schemeClr val="accent1"/>
+          </a:fillRef>
+          <a:effectRef idx="2">
+            <a:schemeClr val="accent1"/>
+          </a:effectRef>
+          <a:fontRef idx="minor">
+            <a:schemeClr val="lt1"/>
+          </a:fontRef>
+        </p:style>
+        <p:txBody>
+          <a:bodyPr rtlCol="0" anchor="ctr"/>
+          <a:lstStyle/>
+          <a:p>
+            <a:pPr algn="ctr"/>
+          </a:p>
+        </p:txBody>
+      </p:sp>
+      <p:sp>
+        <p:nvSpPr>
+          <p:cNvPr id="4" name="Rectangle 3"/>
+          <p:cNvSpPr/>
+          <p:nvPr/>
+        </p:nvSpPr>
+        <p:spPr>
+          <a:xfrm>
+            <a:off x="0" y="786384"/>
+            <a:ext cx="12191695" cy="45720"/>
+          </a:xfrm>
+          <a:prstGeom prst="rect">
+            <a:avLst/>
+          </a:prstGeom>
+          <a:solidFill>
+            <a:srgbClr val="1A7A6D"/>
+          </a:solidFill>
+          <a:ln>
+            <a:noFill/>
+          </a:ln>
+          <a:effectLst/>
+        </p:spPr>
+        <p:style>
+          <a:lnRef idx="1">
+            <a:schemeClr val="accent1"/>
+          </a:lnRef>
+          <a:fillRef idx="3">
+            <a:schemeClr val="accent1"/>
+          </a:fillRef>
+          <a:effectRef idx="2">
+            <a:schemeClr val="accent1"/>
+          </a:effectRef>
+          <a:fontRef idx="minor">
+            <a:schemeClr val="lt1"/>
+          </a:fontRef>
+        </p:style>
+        <p:txBody>
+          <a:bodyPr rtlCol="0" anchor="ctr"/>
+          <a:lstStyle/>
+          <a:p>
+            <a:pPr algn="ctr"/>
+          </a:p>
+        </p:txBody>
+      </p:sp>
+      <p:sp>
+        <p:nvSpPr>
+          <p:cNvPr id="5" name="TextBox 4"/>
+          <p:cNvSpPr txBox="1"/>
+          <p:nvPr/>
+        </p:nvSpPr>
+        <p:spPr>
+          <a:xfrm>
+            <a:off x="365760" y="91440"/>
+            <a:ext cx="11338560" cy="420624"/>
+          </a:xfrm>
+          <a:prstGeom prst="rect">
+            <a:avLst/>
+          </a:prstGeom>
+          <a:noFill/>
+        </p:spPr>
+        <p:txBody>
+          <a:bodyPr wrap="square" lIns="54864" rIns="54864" tIns="27432" bIns="18288">
+            <a:spAutoFit/>
+          </a:bodyPr>
+          <a:lstStyle/>
+          <a:p>
+            <a:pPr algn="l">
+              <a:spcBef>
+                <a:spcPts val="0"/>
+              </a:spcBef>
+              <a:spcAft>
+                <a:spcPts val="0"/>
+              </a:spcAft>
+            </a:pPr>
+            <a:r>
+              <a:rPr sz="2500" b="1" i="0">
+                <a:solidFill>
+                  <a:srgbClr val="FFFFFF"/>
+                </a:solidFill>
+                <a:latin typeface="Calibri"/>
+              </a:rPr>
+              <a:t>From one cell to many</a:t>
+            </a:r>
+          </a:p>
+        </p:txBody>
+      </p:sp>
+      <p:sp>
+        <p:nvSpPr>
+          <p:cNvPr id="6" name="Rectangle 5"/>
+          <p:cNvSpPr/>
+          <p:nvPr/>
+        </p:nvSpPr>
+        <p:spPr>
+          <a:xfrm>
+            <a:off x="0" y="6601968"/>
+            <a:ext cx="12191695" cy="256032"/>
+          </a:xfrm>
+          <a:prstGeom prst="rect">
+            <a:avLst/>
+          </a:prstGeom>
+          <a:solidFill>
+            <a:srgbClr val="F3F6F9"/>
+          </a:solidFill>
+          <a:ln>
+            <a:noFill/>
+          </a:ln>
+          <a:effectLst/>
+        </p:spPr>
+        <p:style>
+          <a:lnRef idx="1">
+            <a:schemeClr val="accent1"/>
+          </a:lnRef>
+          <a:fillRef idx="3">
+            <a:schemeClr val="accent1"/>
+          </a:fillRef>
+          <a:effectRef idx="2">
+            <a:schemeClr val="accent1"/>
+          </a:effectRef>
+          <a:fontRef idx="minor">
+            <a:schemeClr val="lt1"/>
+          </a:fontRef>
+        </p:style>
+        <p:txBody>
+          <a:bodyPr rtlCol="0" anchor="ctr"/>
+          <a:lstStyle/>
+          <a:p>
+            <a:pPr algn="ctr"/>
+          </a:p>
+        </p:txBody>
+      </p:sp>
+      <p:sp>
+        <p:nvSpPr>
+          <p:cNvPr id="7" name="TextBox 6"/>
+          <p:cNvSpPr txBox="1"/>
+          <p:nvPr/>
+        </p:nvSpPr>
+        <p:spPr>
+          <a:xfrm>
+            <a:off x="320040" y="6601968"/>
+            <a:ext cx="9601200" cy="237744"/>
+          </a:xfrm>
+          <a:prstGeom prst="rect">
+            <a:avLst/>
+          </a:prstGeom>
+          <a:noFill/>
+        </p:spPr>
+        <p:txBody>
+          <a:bodyPr wrap="square" lIns="54864" rIns="54864" tIns="27432" bIns="18288">
+            <a:spAutoFit/>
+          </a:bodyPr>
+          <a:lstStyle/>
+          <a:p>
+            <a:pPr algn="l">
+              <a:spcBef>
+                <a:spcPts val="0"/>
+              </a:spcBef>
+              <a:spcAft>
+                <a:spcPts val="0"/>
+              </a:spcAft>
+            </a:pPr>
+            <a:r>
+              <a:rPr sz="1100" b="0" i="0">
+                <a:solidFill>
+                  <a:srgbClr val="4B5563"/>
+                </a:solidFill>
+                <a:latin typeface="Calibri"/>
+              </a:rPr>
+              <a:t>PYD411  ·  Mid-term  ·  Dept of Physics, IIT Delhi  ·  Siddharth Kumar &amp; Soumik Roy</a:t>
+            </a:r>
+          </a:p>
+        </p:txBody>
+      </p:sp>
+      <p:sp>
+        <p:nvSpPr>
+          <p:cNvPr id="8" name="TextBox 7"/>
+          <p:cNvSpPr txBox="1"/>
+          <p:nvPr/>
+        </p:nvSpPr>
+        <p:spPr>
+          <a:xfrm>
+            <a:off x="10607040" y="6601968"/>
+            <a:ext cx="1280160" cy="237744"/>
+          </a:xfrm>
+          <a:prstGeom prst="rect">
+            <a:avLst/>
+          </a:prstGeom>
+          <a:noFill/>
+        </p:spPr>
+        <p:txBody>
+          <a:bodyPr wrap="square" lIns="54864" rIns="54864" tIns="27432" bIns="18288">
+            <a:spAutoFit/>
+          </a:bodyPr>
+          <a:lstStyle/>
+          <a:p>
+            <a:pPr algn="r">
+              <a:spcBef>
+                <a:spcPts val="0"/>
+              </a:spcBef>
+              <a:spcAft>
+                <a:spcPts val="0"/>
+              </a:spcAft>
+            </a:pPr>
+            <a:r>
+              <a:rPr sz="1100" b="0" i="0">
+                <a:solidFill>
+                  <a:srgbClr val="4B5563"/>
+                </a:solidFill>
+                <a:latin typeface="Calibri"/>
+              </a:rPr>
+              <a:t>10 / 10</a:t>
+            </a:r>
+          </a:p>
+        </p:txBody>
+      </p:sp>
+      <p:sp>
+        <p:nvSpPr>
+          <p:cNvPr id="9" name="Rounded Rectangle 8"/>
+          <p:cNvSpPr/>
+          <p:nvPr/>
+        </p:nvSpPr>
+        <p:spPr>
+          <a:xfrm>
+            <a:off x="292608" y="1051560"/>
+            <a:ext cx="2267712" cy="2148840"/>
+          </a:xfrm>
+          <a:prstGeom prst="roundRect">
+            <a:avLst>
+              <a:gd name="adj" fmla="val 8000"/>
+            </a:avLst>
+          </a:prstGeom>
+          <a:solidFill>
+            <a:srgbClr val="F3F6F9"/>
+          </a:solidFill>
+          <a:ln>
+            <a:noFill/>
+          </a:ln>
+          <a:effectLst/>
+        </p:spPr>
+        <p:style>
+          <a:lnRef idx="1">
+            <a:schemeClr val="accent1"/>
+          </a:lnRef>
+          <a:fillRef idx="3">
+            <a:schemeClr val="accent1"/>
+          </a:fillRef>
+          <a:effectRef idx="2">
+            <a:schemeClr val="accent1"/>
+          </a:effectRef>
+          <a:fontRef idx="minor">
+            <a:schemeClr val="lt1"/>
+          </a:fontRef>
+        </p:style>
+        <p:txBody>
+          <a:bodyPr rtlCol="0" anchor="ctr"/>
+          <a:lstStyle/>
+          <a:p>
+            <a:pPr algn="ctr"/>
+          </a:p>
+        </p:txBody>
+      </p:sp>
+      <p:sp>
+        <p:nvSpPr>
+          <p:cNvPr id="10" name="TextBox 9"/>
+          <p:cNvSpPr txBox="1"/>
+          <p:nvPr/>
+        </p:nvSpPr>
+        <p:spPr>
+          <a:xfrm>
+            <a:off x="384048" y="1143000"/>
+            <a:ext cx="2084831" cy="1965960"/>
+          </a:xfrm>
+          <a:prstGeom prst="rect">
+            <a:avLst/>
+          </a:prstGeom>
+          <a:noFill/>
+        </p:spPr>
+        <p:txBody>
+          <a:bodyPr wrap="square" lIns="54864" rIns="54864" tIns="27432" bIns="18288">
+            <a:spAutoFit/>
+          </a:bodyPr>
+          <a:lstStyle/>
+          <a:p>
+            <a:pPr algn="l">
+              <a:spcBef>
+                <a:spcPts val="0"/>
+              </a:spcBef>
+              <a:spcAft>
+                <a:spcPts val="800"/>
+              </a:spcAft>
+            </a:pPr>
+            <a:r>
+              <a:rPr sz="1600" b="1" i="0">
+                <a:solidFill>
+                  <a:srgbClr val="1A7A6D"/>
+                </a:solidFill>
+                <a:latin typeface="Calibri"/>
+              </a:rPr>
+              <a:t>1  Two cells</a:t>
+            </a:r>
+          </a:p>
+          <a:p>
+            <a:pPr algn="l">
+              <a:spcBef>
+                <a:spcPts val="0"/>
+              </a:spcBef>
+              <a:spcAft>
+                <a:spcPts val="600"/>
+              </a:spcAft>
+            </a:pPr>
+            <a:r>
+              <a:rPr sz="1250" b="0" i="0">
+                <a:solidFill>
+                  <a:srgbClr val="1F2937"/>
+                </a:solidFill>
+                <a:latin typeface="Calibri"/>
+              </a:rPr>
+              <a:t>One field pair per cell + repulsive overlap.</a:t>
+            </a:r>
+          </a:p>
+        </p:txBody>
+      </p:sp>
+      <p:sp>
+        <p:nvSpPr>
+          <p:cNvPr id="11" name="Rounded Rectangle 10"/>
+          <p:cNvSpPr/>
+          <p:nvPr/>
+        </p:nvSpPr>
+        <p:spPr>
+          <a:xfrm>
+            <a:off x="2651760" y="1051560"/>
+            <a:ext cx="2267712" cy="2148840"/>
+          </a:xfrm>
+          <a:prstGeom prst="roundRect">
+            <a:avLst>
+              <a:gd name="adj" fmla="val 8000"/>
+            </a:avLst>
+          </a:prstGeom>
+          <a:solidFill>
+            <a:srgbClr val="F3F6F9"/>
+          </a:solidFill>
+          <a:ln>
+            <a:noFill/>
+          </a:ln>
+          <a:effectLst/>
+        </p:spPr>
+        <p:style>
+          <a:lnRef idx="1">
+            <a:schemeClr val="accent1"/>
+          </a:lnRef>
+          <a:fillRef idx="3">
+            <a:schemeClr val="accent1"/>
+          </a:fillRef>
+          <a:effectRef idx="2">
+            <a:schemeClr val="accent1"/>
+          </a:effectRef>
+          <a:fontRef idx="minor">
+            <a:schemeClr val="lt1"/>
+          </a:fontRef>
+        </p:style>
+        <p:txBody>
+          <a:bodyPr rtlCol="0" anchor="ctr"/>
+          <a:lstStyle/>
+          <a:p>
+            <a:pPr algn="ctr"/>
+          </a:p>
+        </p:txBody>
+      </p:sp>
+      <p:sp>
+        <p:nvSpPr>
+          <p:cNvPr id="12" name="TextBox 11"/>
+          <p:cNvSpPr txBox="1"/>
+          <p:nvPr/>
+        </p:nvSpPr>
+        <p:spPr>
+          <a:xfrm>
+            <a:off x="2743200" y="1143000"/>
+            <a:ext cx="2084831" cy="1965960"/>
+          </a:xfrm>
+          <a:prstGeom prst="rect">
+            <a:avLst/>
+          </a:prstGeom>
+          <a:noFill/>
+        </p:spPr>
+        <p:txBody>
+          <a:bodyPr wrap="square" lIns="54864" rIns="54864" tIns="27432" bIns="18288">
+            <a:spAutoFit/>
+          </a:bodyPr>
+          <a:lstStyle/>
+          <a:p>
+            <a:pPr algn="l">
+              <a:spcBef>
+                <a:spcPts val="0"/>
+              </a:spcBef>
+              <a:spcAft>
+                <a:spcPts val="800"/>
+              </a:spcAft>
+            </a:pPr>
+            <a:r>
+              <a:rPr sz="1600" b="1" i="0">
+                <a:solidFill>
+                  <a:srgbClr val="1A7A6D"/>
+                </a:solidFill>
+                <a:latin typeface="Calibri"/>
+              </a:rPr>
+              <a:t>2  Collisions</a:t>
+            </a:r>
+          </a:p>
+          <a:p>
+            <a:pPr algn="l">
+              <a:spcBef>
+                <a:spcPts val="0"/>
+              </a:spcBef>
+              <a:spcAft>
+                <a:spcPts val="600"/>
+              </a:spcAft>
+            </a:pPr>
+            <a:r>
+              <a:rPr sz="1250" b="0" i="0">
+                <a:solidFill>
+                  <a:srgbClr val="1F2937"/>
+                </a:solidFill>
+                <a:latin typeface="Calibri"/>
+              </a:rPr>
+              <a:t>Head-on and glancing interactions.</a:t>
+            </a:r>
+          </a:p>
+        </p:txBody>
+      </p:sp>
+      <p:sp>
+        <p:nvSpPr>
+          <p:cNvPr id="13" name="Rounded Rectangle 12"/>
+          <p:cNvSpPr/>
+          <p:nvPr/>
+        </p:nvSpPr>
+        <p:spPr>
+          <a:xfrm>
+            <a:off x="5010912" y="1051560"/>
+            <a:ext cx="2267712" cy="2148840"/>
+          </a:xfrm>
+          <a:prstGeom prst="roundRect">
+            <a:avLst>
+              <a:gd name="adj" fmla="val 8000"/>
+            </a:avLst>
+          </a:prstGeom>
+          <a:solidFill>
+            <a:srgbClr val="F3F6F9"/>
+          </a:solidFill>
+          <a:ln>
+            <a:noFill/>
+          </a:ln>
+          <a:effectLst/>
+        </p:spPr>
+        <p:style>
+          <a:lnRef idx="1">
+            <a:schemeClr val="accent1"/>
+          </a:lnRef>
+          <a:fillRef idx="3">
+            <a:schemeClr val="accent1"/>
+          </a:fillRef>
+          <a:effectRef idx="2">
+            <a:schemeClr val="accent1"/>
+          </a:effectRef>
+          <a:fontRef idx="minor">
+            <a:schemeClr val="lt1"/>
+          </a:fontRef>
+        </p:style>
+        <p:txBody>
+          <a:bodyPr rtlCol="0" anchor="ctr"/>
+          <a:lstStyle/>
+          <a:p>
+            <a:pPr algn="ctr"/>
+          </a:p>
+        </p:txBody>
+      </p:sp>
+      <p:sp>
+        <p:nvSpPr>
+          <p:cNvPr id="14" name="TextBox 13"/>
+          <p:cNvSpPr txBox="1"/>
+          <p:nvPr/>
+        </p:nvSpPr>
+        <p:spPr>
+          <a:xfrm>
+            <a:off x="5102352" y="1143000"/>
+            <a:ext cx="2084831" cy="1965960"/>
+          </a:xfrm>
+          <a:prstGeom prst="rect">
+            <a:avLst/>
+          </a:prstGeom>
+          <a:noFill/>
+        </p:spPr>
+        <p:txBody>
+          <a:bodyPr wrap="square" lIns="54864" rIns="54864" tIns="27432" bIns="18288">
+            <a:spAutoFit/>
+          </a:bodyPr>
+          <a:lstStyle/>
+          <a:p>
+            <a:pPr algn="l">
+              <a:spcBef>
+                <a:spcPts val="0"/>
+              </a:spcBef>
+              <a:spcAft>
+                <a:spcPts val="800"/>
+              </a:spcAft>
+            </a:pPr>
+            <a:r>
+              <a:rPr sz="1600" b="1" i="0">
+                <a:solidFill>
+                  <a:srgbClr val="1A7A6D"/>
+                </a:solidFill>
+                <a:latin typeface="Calibri"/>
+              </a:rPr>
+              <a:t>3  Polarity</a:t>
+            </a:r>
+          </a:p>
+          <a:p>
+            <a:pPr algn="l">
+              <a:spcBef>
+                <a:spcPts val="0"/>
+              </a:spcBef>
+              <a:spcAft>
+                <a:spcPts val="600"/>
+              </a:spcAft>
+            </a:pPr>
+            <a:r>
+              <a:rPr sz="1250" b="0" i="0">
+                <a:solidFill>
+                  <a:srgbClr val="1F2937"/>
+                </a:solidFill>
+                <a:latin typeface="Calibri"/>
+              </a:rPr>
+              <a:t>Allow cells to choose their own direction.</a:t>
+            </a:r>
+          </a:p>
+        </p:txBody>
+      </p:sp>
+      <p:sp>
+        <p:nvSpPr>
+          <p:cNvPr id="15" name="Rounded Rectangle 14"/>
+          <p:cNvSpPr/>
+          <p:nvPr/>
+        </p:nvSpPr>
+        <p:spPr>
+          <a:xfrm>
+            <a:off x="7370064" y="1051560"/>
+            <a:ext cx="2267712" cy="2148840"/>
+          </a:xfrm>
+          <a:prstGeom prst="roundRect">
+            <a:avLst>
+              <a:gd name="adj" fmla="val 8000"/>
+            </a:avLst>
+          </a:prstGeom>
+          <a:solidFill>
+            <a:srgbClr val="F3F6F9"/>
+          </a:solidFill>
+          <a:ln>
+            <a:noFill/>
+          </a:ln>
+          <a:effectLst/>
+        </p:spPr>
+        <p:style>
+          <a:lnRef idx="1">
+            <a:schemeClr val="accent1"/>
+          </a:lnRef>
+          <a:fillRef idx="3">
+            <a:schemeClr val="accent1"/>
+          </a:fillRef>
+          <a:effectRef idx="2">
+            <a:schemeClr val="accent1"/>
+          </a:effectRef>
+          <a:fontRef idx="minor">
+            <a:schemeClr val="lt1"/>
+          </a:fontRef>
+        </p:style>
+        <p:txBody>
+          <a:bodyPr rtlCol="0" anchor="ctr"/>
+          <a:lstStyle/>
+          <a:p>
+            <a:pPr algn="ctr"/>
+          </a:p>
+        </p:txBody>
+      </p:sp>
+      <p:sp>
+        <p:nvSpPr>
+          <p:cNvPr id="16" name="TextBox 15"/>
+          <p:cNvSpPr txBox="1"/>
+          <p:nvPr/>
+        </p:nvSpPr>
+        <p:spPr>
+          <a:xfrm>
+            <a:off x="7461504" y="1143000"/>
+            <a:ext cx="2084831" cy="1965960"/>
+          </a:xfrm>
+          <a:prstGeom prst="rect">
+            <a:avLst/>
+          </a:prstGeom>
+          <a:noFill/>
+        </p:spPr>
+        <p:txBody>
+          <a:bodyPr wrap="square" lIns="54864" rIns="54864" tIns="27432" bIns="18288">
+            <a:spAutoFit/>
+          </a:bodyPr>
+          <a:lstStyle/>
+          <a:p>
+            <a:pPr algn="l">
+              <a:spcBef>
+                <a:spcPts val="0"/>
+              </a:spcBef>
+              <a:spcAft>
+                <a:spcPts val="800"/>
+              </a:spcAft>
+            </a:pPr>
+            <a:r>
+              <a:rPr sz="1600" b="1" i="0">
+                <a:solidFill>
+                  <a:srgbClr val="1A7A6D"/>
+                </a:solidFill>
+                <a:latin typeface="Calibri"/>
+              </a:rPr>
+              <a:t>4  Adhesion</a:t>
+            </a:r>
+          </a:p>
+          <a:p>
+            <a:pPr algn="l">
+              <a:spcBef>
+                <a:spcPts val="0"/>
+              </a:spcBef>
+              <a:spcAft>
+                <a:spcPts val="600"/>
+              </a:spcAft>
+            </a:pPr>
+            <a:r>
+              <a:rPr sz="1250" b="0" i="0">
+                <a:solidFill>
+                  <a:srgbClr val="1F2937"/>
+                </a:solidFill>
+                <a:latin typeface="Calibri"/>
+              </a:rPr>
+              <a:t>Load-dependent friction ξ.</a:t>
+            </a:r>
+          </a:p>
+        </p:txBody>
+      </p:sp>
+      <p:sp>
+        <p:nvSpPr>
+          <p:cNvPr id="17" name="Rounded Rectangle 16"/>
+          <p:cNvSpPr/>
+          <p:nvPr/>
+        </p:nvSpPr>
+        <p:spPr>
+          <a:xfrm>
+            <a:off x="9729216" y="1051560"/>
+            <a:ext cx="2267712" cy="2148840"/>
+          </a:xfrm>
+          <a:prstGeom prst="roundRect">
+            <a:avLst>
+              <a:gd name="adj" fmla="val 8000"/>
+            </a:avLst>
+          </a:prstGeom>
+          <a:solidFill>
+            <a:srgbClr val="F3F6F9"/>
+          </a:solidFill>
+          <a:ln>
+            <a:noFill/>
+          </a:ln>
+          <a:effectLst/>
+        </p:spPr>
+        <p:style>
+          <a:lnRef idx="1">
+            <a:schemeClr val="accent1"/>
+          </a:lnRef>
+          <a:fillRef idx="3">
+            <a:schemeClr val="accent1"/>
+          </a:fillRef>
+          <a:effectRef idx="2">
+            <a:schemeClr val="accent1"/>
+          </a:effectRef>
+          <a:fontRef idx="minor">
+            <a:schemeClr val="lt1"/>
+          </a:fontRef>
+        </p:style>
+        <p:txBody>
+          <a:bodyPr rtlCol="0" anchor="ctr"/>
+          <a:lstStyle/>
+          <a:p>
+            <a:pPr algn="ctr"/>
+          </a:p>
+        </p:txBody>
+      </p:sp>
+      <p:sp>
+        <p:nvSpPr>
+          <p:cNvPr id="18" name="TextBox 17"/>
+          <p:cNvSpPr txBox="1"/>
+          <p:nvPr/>
+        </p:nvSpPr>
+        <p:spPr>
+          <a:xfrm>
+            <a:off x="9820656" y="1143000"/>
+            <a:ext cx="2084831" cy="1965960"/>
+          </a:xfrm>
+          <a:prstGeom prst="rect">
+            <a:avLst/>
+          </a:prstGeom>
+          <a:noFill/>
+        </p:spPr>
+        <p:txBody>
+          <a:bodyPr wrap="square" lIns="54864" rIns="54864" tIns="27432" bIns="18288">
+            <a:spAutoFit/>
+          </a:bodyPr>
+          <a:lstStyle/>
+          <a:p>
+            <a:pPr algn="l">
+              <a:spcBef>
+                <a:spcPts val="0"/>
+              </a:spcBef>
+              <a:spcAft>
+                <a:spcPts val="800"/>
+              </a:spcAft>
+            </a:pPr>
+            <a:r>
+              <a:rPr sz="1600" b="1" i="0">
+                <a:solidFill>
+                  <a:srgbClr val="1A7A6D"/>
+                </a:solidFill>
+                <a:latin typeface="Calibri"/>
+              </a:rPr>
+              <a:t>5  Collectives</a:t>
+            </a:r>
+          </a:p>
+          <a:p>
+            <a:pPr algn="l">
+              <a:spcBef>
+                <a:spcPts val="0"/>
+              </a:spcBef>
+              <a:spcAft>
+                <a:spcPts val="600"/>
+              </a:spcAft>
+            </a:pPr>
+            <a:r>
+              <a:rPr sz="1250" b="0" i="0">
+                <a:solidFill>
+                  <a:srgbClr val="1F2937"/>
+                </a:solidFill>
+                <a:latin typeface="Calibri"/>
+              </a:rPr>
+              <a:t>Tens of cells: jamming and neighbour alignment.</a:t>
+            </a:r>
+          </a:p>
+        </p:txBody>
+      </p:sp>
+      <p:sp>
+        <p:nvSpPr>
+          <p:cNvPr id="19" name="Rounded Rectangle 18"/>
+          <p:cNvSpPr/>
+          <p:nvPr/>
+        </p:nvSpPr>
+        <p:spPr>
+          <a:xfrm>
+            <a:off x="292608" y="3429000"/>
+            <a:ext cx="11594592" cy="2926080"/>
+          </a:xfrm>
+          <a:prstGeom prst="roundRect">
+            <a:avLst>
+              <a:gd name="adj" fmla="val 8000"/>
+            </a:avLst>
+          </a:prstGeom>
+          <a:solidFill>
+            <a:srgbClr val="0B3D5C"/>
+          </a:solidFill>
+          <a:ln>
+            <a:noFill/>
+          </a:ln>
+          <a:effectLst/>
+        </p:spPr>
+        <p:style>
+          <a:lnRef idx="1">
+            <a:schemeClr val="accent1"/>
+          </a:lnRef>
+          <a:fillRef idx="3">
+            <a:schemeClr val="accent1"/>
+          </a:fillRef>
+          <a:effectRef idx="2">
+            <a:schemeClr val="accent1"/>
+          </a:effectRef>
+          <a:fontRef idx="minor">
+            <a:schemeClr val="lt1"/>
+          </a:fontRef>
+        </p:style>
+        <p:txBody>
+          <a:bodyPr rtlCol="0" anchor="ctr"/>
+          <a:lstStyle/>
+          <a:p>
+            <a:pPr algn="ctr"/>
+          </a:p>
+        </p:txBody>
+      </p:sp>
+      <p:sp>
+        <p:nvSpPr>
+          <p:cNvPr id="20" name="TextBox 19"/>
+          <p:cNvSpPr txBox="1"/>
+          <p:nvPr/>
+        </p:nvSpPr>
+        <p:spPr>
+          <a:xfrm>
+            <a:off x="548640" y="3611880"/>
+            <a:ext cx="11109960" cy="2606040"/>
+          </a:xfrm>
+          <a:prstGeom prst="rect">
+            <a:avLst/>
+          </a:prstGeom>
+          <a:noFill/>
+        </p:spPr>
+        <p:txBody>
+          <a:bodyPr wrap="square" lIns="54864" rIns="54864" tIns="27432" bIns="18288">
+            <a:spAutoFit/>
+          </a:bodyPr>
+          <a:lstStyle/>
+          <a:p>
+            <a:pPr algn="l">
+              <a:spcBef>
+                <a:spcPts val="0"/>
+              </a:spcBef>
+              <a:spcAft>
+                <a:spcPts val="1600"/>
+              </a:spcAft>
+            </a:pPr>
+            <a:r>
+              <a:rPr sz="3200" b="1" i="0">
+                <a:solidFill>
+                  <a:srgbClr val="FFFFFF"/>
+                </a:solidFill>
+                <a:latin typeface="Calibri"/>
+              </a:rPr>
+              <a:t>Thank you — Questions</a:t>
+            </a:r>
+          </a:p>
+          <a:p>
+            <a:pPr algn="l">
+              <a:spcBef>
+                <a:spcPts val="0"/>
+              </a:spcBef>
+              <a:spcAft>
+                <a:spcPts val="800"/>
+              </a:spcAft>
+            </a:pPr>
+            <a:r>
+              <a:rPr sz="1600" b="0" i="0">
+                <a:solidFill>
+                  <a:srgbClr val="FFFFFF"/>
+                </a:solidFill>
+                <a:latin typeface="Calibri"/>
+              </a:rPr>
+              <a:t>Siddharth Kumar  (2023PH10741)     ·     Soumik Roy  (2023PH10756)</a:t>
+            </a:r>
+          </a:p>
+          <a:p>
+            <a:pPr algn="l">
+              <a:spcBef>
+                <a:spcPts val="0"/>
+              </a:spcBef>
+              <a:spcAft>
+                <a:spcPts val="600"/>
+              </a:spcAft>
+            </a:pPr>
+            <a:r>
+              <a:rPr sz="1500" b="0" i="0">
+                <a:solidFill>
+                  <a:srgbClr val="C5D4DE"/>
+                </a:solidFill>
+                <a:latin typeface="Calibri"/>
+              </a:rPr>
+              <a:t>Adviser: Prof. Sujin B. Babu     ·     Department of Physics, IIT Delhi</a:t>
             </a:r>
           </a:p>
         </p:txBody>
@@ -4810,7 +5862,7 @@
                 </a:solidFill>
                 <a:latin typeface="Calibri"/>
               </a:rPr>
-              <a:t>2 / 9</a:t>
+              <a:t>2 / 10</a:t>
             </a:r>
           </a:p>
         </p:txBody>
@@ -6672,7 +7724,7 @@
                 </a:solidFill>
                 <a:latin typeface="Calibri"/>
               </a:rPr>
-              <a:t>3 / 9</a:t>
+              <a:t>3 / 10</a:t>
             </a:r>
           </a:p>
         </p:txBody>
@@ -8272,7 +9324,7 @@
                 </a:solidFill>
                 <a:latin typeface="Calibri"/>
               </a:rPr>
-              <a:t>4 / 9</a:t>
+              <a:t>4 / 10</a:t>
             </a:r>
           </a:p>
         </p:txBody>
@@ -10614,7 +11666,7 @@
                 </a:solidFill>
                 <a:latin typeface="Calibri"/>
               </a:rPr>
-              <a:t>5 / 9</a:t>
+              <a:t>5 / 10</a:t>
             </a:r>
           </a:p>
         </p:txBody>
@@ -11842,7 +12894,7 @@
                 </a:solidFill>
                 <a:latin typeface="Calibri"/>
               </a:rPr>
-              <a:t>6 / 9</a:t>
+              <a:t>6 / 10</a:t>
             </a:r>
           </a:p>
         </p:txBody>
@@ -13080,7 +14132,7 @@
                 </a:solidFill>
                 <a:latin typeface="Calibri"/>
               </a:rPr>
-              <a:t>7 / 9</a:t>
+              <a:t>7 / 10</a:t>
             </a:r>
           </a:p>
         </p:txBody>
@@ -14546,14 +15598,56 @@
                 </a:solidFill>
                 <a:latin typeface="Calibri"/>
               </a:rPr>
-              <a:t>What the simulations establish</a:t>
-            </a:r>
-          </a:p>
-        </p:txBody>
-      </p:sp>
-      <p:sp>
-        <p:nvSpPr>
-          <p:cNvPr id="6" name="Rectangle 5"/>
+              <a:t>Already underway: a first two-cell experiment</a:t>
+            </a:r>
+          </a:p>
+        </p:txBody>
+      </p:sp>
+      <p:sp>
+        <p:nvSpPr>
+          <p:cNvPr id="6" name="TextBox 5"/>
+          <p:cNvSpPr txBox="1"/>
+          <p:nvPr/>
+        </p:nvSpPr>
+        <p:spPr>
+          <a:xfrm>
+            <a:off x="365760" y="457200"/>
+            <a:ext cx="11338560" cy="292608"/>
+          </a:xfrm>
+          <a:prstGeom prst="rect">
+            <a:avLst/>
+          </a:prstGeom>
+          <a:noFill/>
+        </p:spPr>
+        <p:txBody>
+          <a:bodyPr wrap="square" lIns="54864" rIns="54864" tIns="27432" bIns="18288">
+            <a:spAutoFit/>
+          </a:bodyPr>
+          <a:lstStyle/>
+          <a:p>
+            <a:pPr algn="l">
+              <a:spcBef>
+                <a:spcPts val="0"/>
+              </a:spcBef>
+              <a:spcAft>
+                <a:spcPts val="0"/>
+              </a:spcAft>
+            </a:pPr>
+            <a:r>
+              <a:rPr sz="1250" b="0" i="0">
+                <a:solidFill>
+                  <a:srgbClr val="C5D4DE"/>
+                </a:solidFill>
+                <a:latin typeface="Calibri"/>
+              </a:rPr>
+              <a:t>Same Version 4 physics per cell, one new free-energy term couples them</a:t>
+            </a:r>
+          </a:p>
+        </p:txBody>
+      </p:sp>
+      <p:sp>
+        <p:nvSpPr>
+          <p:cNvPr id="7" name="Rectangle 6"/>
           <p:cNvSpPr/>
           <p:nvPr/>
         </p:nvSpPr>
@@ -14597,7 +15691,7 @@
       </p:sp>
       <p:sp>
         <p:nvSpPr>
-          <p:cNvPr id="7" name="TextBox 6"/>
+          <p:cNvPr id="8" name="TextBox 7"/>
           <p:cNvSpPr txBox="1"/>
           <p:nvPr/>
         </p:nvSpPr>
@@ -14639,7 +15733,7 @@
       </p:sp>
       <p:sp>
         <p:nvSpPr>
-          <p:cNvPr id="8" name="TextBox 7"/>
+          <p:cNvPr id="9" name="TextBox 8"/>
           <p:cNvSpPr txBox="1"/>
           <p:nvPr/>
         </p:nvSpPr>
@@ -14674,21 +15768,140 @@
                 </a:solidFill>
                 <a:latin typeface="Calibri"/>
               </a:rPr>
-              <a:t>8 / 9</a:t>
-            </a:r>
-          </a:p>
-        </p:txBody>
-      </p:sp>
-      <p:sp>
-        <p:nvSpPr>
-          <p:cNvPr id="9" name="Rounded Rectangle 8"/>
+              <a:t>8 / 10</a:t>
+            </a:r>
+          </a:p>
+        </p:txBody>
+      </p:sp>
+      <p:pic>
+        <p:nvPicPr>
+          <p:cNvPr id="10" name="two_cell_collision.mp4">
+            <a:hlinkClick r:id="" action="ppaction://media"/>
+          </p:cNvPr>
+          <p:cNvPicPr>
+            <a:picLocks noChangeAspect="1"/>
+          </p:cNvPicPr>
+          <p:nvPr>
+            <a:videoFile r:link="rId3"/>
+            <p:extLst>
+              <p:ext uri="{DAA4B4D4-6D71-4841-9C94-3DE7FCFB9230}">
+                <p14:media xmlns:p14="http://schemas.microsoft.com/office/powerpoint/2010/main" r:embed="rId2"/>
+              </p:ext>
+            </p:extLst>
+          </p:nvPr>
+        </p:nvPicPr>
+        <p:blipFill>
+          <a:blip r:embed="rId4"/>
+          <a:stretch>
+            <a:fillRect/>
+          </a:stretch>
+        </p:blipFill>
+        <p:spPr>
+          <a:xfrm>
+            <a:off x="411480" y="1051560"/>
+            <a:ext cx="4617720" cy="4617720"/>
+          </a:xfrm>
+          <a:prstGeom prst="rect">
+            <a:avLst/>
+          </a:prstGeom>
+        </p:spPr>
+      </p:pic>
+      <p:sp>
+        <p:nvSpPr>
+          <p:cNvPr id="11" name="Rectangle 10"/>
           <p:cNvSpPr/>
           <p:nvPr/>
         </p:nvSpPr>
         <p:spPr>
           <a:xfrm>
-            <a:off x="365760" y="1051560"/>
-            <a:ext cx="11430000" cy="969264"/>
+            <a:off x="411480" y="5705856"/>
+            <a:ext cx="4617720" cy="914"/>
+          </a:xfrm>
+          <a:prstGeom prst="rect">
+            <a:avLst/>
+          </a:prstGeom>
+          <a:solidFill>
+            <a:srgbClr val="FFFFFF"/>
+          </a:solidFill>
+          <a:ln>
+            <a:noFill/>
+          </a:ln>
+          <a:effectLst/>
+        </p:spPr>
+        <p:style>
+          <a:lnRef idx="1">
+            <a:schemeClr val="accent1"/>
+          </a:lnRef>
+          <a:fillRef idx="3">
+            <a:schemeClr val="accent1"/>
+          </a:fillRef>
+          <a:effectRef idx="2">
+            <a:schemeClr val="accent1"/>
+          </a:effectRef>
+          <a:fontRef idx="minor">
+            <a:schemeClr val="lt1"/>
+          </a:fontRef>
+        </p:style>
+        <p:txBody>
+          <a:bodyPr rtlCol="0" anchor="ctr"/>
+          <a:lstStyle/>
+          <a:p>
+            <a:pPr algn="ctr"/>
+          </a:p>
+        </p:txBody>
+      </p:sp>
+      <p:sp>
+        <p:nvSpPr>
+          <p:cNvPr id="12" name="TextBox 11"/>
+          <p:cNvSpPr txBox="1"/>
+          <p:nvPr/>
+        </p:nvSpPr>
+        <p:spPr>
+          <a:xfrm>
+            <a:off x="411480" y="5724144"/>
+            <a:ext cx="4617720" cy="292608"/>
+          </a:xfrm>
+          <a:prstGeom prst="rect">
+            <a:avLst/>
+          </a:prstGeom>
+          <a:noFill/>
+        </p:spPr>
+        <p:txBody>
+          <a:bodyPr wrap="square" lIns="54864" rIns="54864" tIns="27432" bIns="18288">
+            <a:spAutoFit/>
+          </a:bodyPr>
+          <a:lstStyle/>
+          <a:p>
+            <a:pPr algn="ctr">
+              <a:spcBef>
+                <a:spcPts val="0"/>
+              </a:spcBef>
+              <a:spcAft>
+                <a:spcPts val="0"/>
+              </a:spcAft>
+            </a:pPr>
+            <a:r>
+              <a:rPr sz="1150" b="0" i="0">
+                <a:solidFill>
+                  <a:srgbClr val="4B5563"/>
+                </a:solidFill>
+                <a:latin typeface="Calibri"/>
+              </a:rPr>
+              <a:t>3 s clip — click to play in Slide Show mode</a:t>
+            </a:r>
+          </a:p>
+        </p:txBody>
+      </p:sp>
+      <p:sp>
+        <p:nvSpPr>
+          <p:cNvPr id="13" name="Rounded Rectangle 12"/>
+          <p:cNvSpPr/>
+          <p:nvPr/>
+        </p:nvSpPr>
+        <p:spPr>
+          <a:xfrm>
+            <a:off x="5349240" y="1051560"/>
+            <a:ext cx="6522415" cy="4846320"/>
           </a:xfrm>
           <a:prstGeom prst="roundRect">
             <a:avLst>
@@ -14727,58 +15940,14 @@
       </p:sp>
       <p:sp>
         <p:nvSpPr>
-          <p:cNvPr id="10" name="Rectangle 9"/>
-          <p:cNvSpPr/>
-          <p:nvPr/>
-        </p:nvSpPr>
-        <p:spPr>
-          <a:xfrm>
-            <a:off x="365760" y="1051560"/>
-            <a:ext cx="109728" cy="969264"/>
-          </a:xfrm>
-          <a:prstGeom prst="rect">
-            <a:avLst/>
-          </a:prstGeom>
-          <a:solidFill>
-            <a:srgbClr val="1A7A6D"/>
-          </a:solidFill>
-          <a:ln>
-            <a:noFill/>
-          </a:ln>
-          <a:effectLst/>
-        </p:spPr>
-        <p:style>
-          <a:lnRef idx="1">
-            <a:schemeClr val="accent1"/>
-          </a:lnRef>
-          <a:fillRef idx="3">
-            <a:schemeClr val="accent1"/>
-          </a:fillRef>
-          <a:effectRef idx="2">
-            <a:schemeClr val="accent1"/>
-          </a:effectRef>
-          <a:fontRef idx="minor">
-            <a:schemeClr val="lt1"/>
-          </a:fontRef>
-        </p:style>
-        <p:txBody>
-          <a:bodyPr rtlCol="0" anchor="ctr"/>
-          <a:lstStyle/>
-          <a:p>
-            <a:pPr algn="ctr"/>
-          </a:p>
-        </p:txBody>
-      </p:sp>
-      <p:sp>
-        <p:nvSpPr>
-          <p:cNvPr id="11" name="TextBox 10"/>
+          <p:cNvPr id="14" name="TextBox 13"/>
           <p:cNvSpPr txBox="1"/>
           <p:nvPr/>
         </p:nvSpPr>
         <p:spPr>
           <a:xfrm>
-            <a:off x="594360" y="1106424"/>
-            <a:ext cx="640080" cy="822960"/>
+            <a:off x="5550408" y="1170432"/>
+            <a:ext cx="6120079" cy="4617720"/>
           </a:xfrm>
           <a:prstGeom prst="rect">
             <a:avLst/>
@@ -14790,67 +15959,6 @@
             <a:spAutoFit/>
           </a:bodyPr>
           <a:lstStyle/>
-          <a:p>
-            <a:pPr algn="l">
-              <a:spcBef>
-                <a:spcPts val="0"/>
-              </a:spcBef>
-              <a:spcAft>
-                <a:spcPts val="0"/>
-              </a:spcAft>
-            </a:pPr>
-            <a:r>
-              <a:rPr sz="2200" b="1" i="0">
-                <a:solidFill>
-                  <a:srgbClr val="1A7A6D"/>
-                </a:solidFill>
-                <a:latin typeface="Calibri"/>
-              </a:rPr>
-              <a:t>01</a:t>
-            </a:r>
-          </a:p>
-        </p:txBody>
-      </p:sp>
-      <p:sp>
-        <p:nvSpPr>
-          <p:cNvPr id="12" name="TextBox 11"/>
-          <p:cNvSpPr txBox="1"/>
-          <p:nvPr/>
-        </p:nvSpPr>
-        <p:spPr>
-          <a:xfrm>
-            <a:off x="1280160" y="1124712"/>
-            <a:ext cx="10287000" cy="822960"/>
-          </a:xfrm>
-          <a:prstGeom prst="rect">
-            <a:avLst/>
-          </a:prstGeom>
-          <a:noFill/>
-        </p:spPr>
-        <p:txBody>
-          <a:bodyPr wrap="square" lIns="54864" rIns="54864" tIns="27432" bIns="18288">
-            <a:spAutoFit/>
-          </a:bodyPr>
-          <a:lstStyle/>
-          <a:p>
-            <a:pPr algn="l">
-              <a:spcBef>
-                <a:spcPts val="0"/>
-              </a:spcBef>
-              <a:spcAft>
-                <a:spcPts val="400"/>
-              </a:spcAft>
-            </a:pPr>
-            <a:r>
-              <a:rPr sz="1600" b="1" i="0">
-                <a:solidFill>
-                  <a:srgbClr val="0B3D5C"/>
-                </a:solidFill>
-                <a:latin typeface="Calibri"/>
-              </a:rPr>
-              <a:t>A spatial gradient in treadmilling can generate a leading protrusion.</a:t>
-            </a:r>
-          </a:p>
           <a:p>
             <a:pPr algn="l">
               <a:spcBef>
@@ -14861,187 +15969,132 @@
               </a:spcAft>
             </a:pPr>
             <a:r>
-              <a:rPr sz="1250" b="0" i="0">
-                <a:solidFill>
-                  <a:srgbClr val="4B5563"/>
+              <a:rPr sz="1600" b="1" i="0">
+                <a:solidFill>
+                  <a:srgbClr val="0B3D5C"/>
                 </a:solidFill>
                 <a:latin typeface="Calibri"/>
               </a:rPr>
-              <a:t>V2</a:t>
-            </a:r>
-          </a:p>
-        </p:txBody>
-      </p:sp>
-      <p:sp>
-        <p:nvSpPr>
-          <p:cNvPr id="13" name="Rounded Rectangle 12"/>
-          <p:cNvSpPr/>
-          <p:nvPr/>
-        </p:nvSpPr>
-        <p:spPr>
-          <a:xfrm>
-            <a:off x="365760" y="2130552"/>
-            <a:ext cx="11430000" cy="969264"/>
-          </a:xfrm>
-          <a:prstGeom prst="roundRect">
-            <a:avLst>
-              <a:gd name="adj" fmla="val 8000"/>
-            </a:avLst>
-          </a:prstGeom>
-          <a:solidFill>
-            <a:srgbClr val="F3F6F9"/>
-          </a:solidFill>
-          <a:ln>
-            <a:noFill/>
-          </a:ln>
-          <a:effectLst/>
-        </p:spPr>
-        <p:style>
-          <a:lnRef idx="1">
-            <a:schemeClr val="accent1"/>
-          </a:lnRef>
-          <a:fillRef idx="3">
-            <a:schemeClr val="accent1"/>
-          </a:fillRef>
-          <a:effectRef idx="2">
-            <a:schemeClr val="accent1"/>
-          </a:effectRef>
-          <a:fontRef idx="minor">
-            <a:schemeClr val="lt1"/>
-          </a:fontRef>
-        </p:style>
-        <p:txBody>
-          <a:bodyPr rtlCol="0" anchor="ctr"/>
-          <a:lstStyle/>
-          <a:p>
-            <a:pPr algn="ctr"/>
-          </a:p>
-        </p:txBody>
-      </p:sp>
-      <p:sp>
-        <p:nvSpPr>
-          <p:cNvPr id="14" name="Rectangle 13"/>
-          <p:cNvSpPr/>
-          <p:nvPr/>
-        </p:nvSpPr>
-        <p:spPr>
-          <a:xfrm>
-            <a:off x="365760" y="2130552"/>
-            <a:ext cx="109728" cy="969264"/>
-          </a:xfrm>
-          <a:prstGeom prst="rect">
-            <a:avLst/>
-          </a:prstGeom>
-          <a:solidFill>
-            <a:srgbClr val="1A7A6D"/>
-          </a:solidFill>
-          <a:ln>
-            <a:noFill/>
-          </a:ln>
-          <a:effectLst/>
-        </p:spPr>
-        <p:style>
-          <a:lnRef idx="1">
-            <a:schemeClr val="accent1"/>
-          </a:lnRef>
-          <a:fillRef idx="3">
-            <a:schemeClr val="accent1"/>
-          </a:fillRef>
-          <a:effectRef idx="2">
-            <a:schemeClr val="accent1"/>
-          </a:effectRef>
-          <a:fontRef idx="minor">
-            <a:schemeClr val="lt1"/>
-          </a:fontRef>
-        </p:style>
-        <p:txBody>
-          <a:bodyPr rtlCol="0" anchor="ctr"/>
-          <a:lstStyle/>
-          <a:p>
-            <a:pPr algn="ctr"/>
-          </a:p>
-        </p:txBody>
-      </p:sp>
-      <p:sp>
-        <p:nvSpPr>
-          <p:cNvPr id="15" name="TextBox 14"/>
-          <p:cNvSpPr txBox="1"/>
-          <p:nvPr/>
-        </p:nvSpPr>
-        <p:spPr>
-          <a:xfrm>
-            <a:off x="594360" y="2185416"/>
-            <a:ext cx="640080" cy="822960"/>
-          </a:xfrm>
-          <a:prstGeom prst="rect">
-            <a:avLst/>
-          </a:prstGeom>
-          <a:noFill/>
-        </p:spPr>
-        <p:txBody>
-          <a:bodyPr wrap="square" lIns="54864" rIns="54864" tIns="27432" bIns="18288">
-            <a:spAutoFit/>
-          </a:bodyPr>
-          <a:lstStyle/>
+              <a:t>One new term</a:t>
+            </a:r>
+          </a:p>
           <a:p>
             <a:pPr algn="l">
               <a:spcBef>
                 <a:spcPts val="0"/>
               </a:spcBef>
               <a:spcAft>
-                <a:spcPts val="0"/>
+                <a:spcPts val="800"/>
               </a:spcAft>
             </a:pPr>
             <a:r>
-              <a:rPr sz="2200" b="1" i="0">
-                <a:solidFill>
-                  <a:srgbClr val="1A7A6D"/>
-                </a:solidFill>
-                <a:latin typeface="Calibri"/>
-              </a:rPr>
-              <a:t>02</a:t>
-            </a:r>
-          </a:p>
-        </p:txBody>
-      </p:sp>
-      <p:sp>
-        <p:nvSpPr>
-          <p:cNvPr id="16" name="TextBox 15"/>
-          <p:cNvSpPr txBox="1"/>
-          <p:nvPr/>
-        </p:nvSpPr>
-        <p:spPr>
-          <a:xfrm>
-            <a:off x="1280160" y="2203704"/>
-            <a:ext cx="10287000" cy="822960"/>
-          </a:xfrm>
-          <a:prstGeom prst="rect">
-            <a:avLst/>
-          </a:prstGeom>
-          <a:noFill/>
-        </p:spPr>
-        <p:txBody>
-          <a:bodyPr wrap="square" lIns="54864" rIns="54864" tIns="27432" bIns="18288">
-            <a:spAutoFit/>
-          </a:bodyPr>
-          <a:lstStyle/>
+              <a:rPr sz="1600" b="0" i="0">
+                <a:solidFill>
+                  <a:srgbClr val="0B3D5C"/>
+                </a:solidFill>
+                <a:latin typeface="Cambria Math"/>
+              </a:rPr>
+              <a:t>F</a:t>
+            </a:r>
+            <a:r>
+              <a:rPr sz="1600" b="0" i="0" baseline="-25000">
+                <a:solidFill>
+                  <a:srgbClr val="0B3D5C"/>
+                </a:solidFill>
+                <a:latin typeface="Cambria Math"/>
+              </a:rPr>
+              <a:t>rep</a:t>
+            </a:r>
+            <a:r>
+              <a:rPr sz="1600" b="0" i="0">
+                <a:solidFill>
+                  <a:srgbClr val="0B3D5C"/>
+                </a:solidFill>
+                <a:latin typeface="Cambria Math"/>
+              </a:rPr>
+              <a:t> = k</a:t>
+            </a:r>
+            <a:r>
+              <a:rPr sz="1600" b="0" i="0" baseline="-25000">
+                <a:solidFill>
+                  <a:srgbClr val="0B3D5C"/>
+                </a:solidFill>
+                <a:latin typeface="Cambria Math"/>
+              </a:rPr>
+              <a:t>rep</a:t>
+            </a:r>
+            <a:r>
+              <a:rPr sz="1600" b="0" i="0">
+                <a:solidFill>
+                  <a:srgbClr val="0B3D5C"/>
+                </a:solidFill>
+                <a:latin typeface="Cambria Math"/>
+              </a:rPr>
+              <a:t> ∫ φ</a:t>
+            </a:r>
+            <a:r>
+              <a:rPr sz="1600" b="0" i="0" baseline="-25000">
+                <a:solidFill>
+                  <a:srgbClr val="0B3D5C"/>
+                </a:solidFill>
+                <a:latin typeface="Cambria Math"/>
+              </a:rPr>
+              <a:t>1</a:t>
+            </a:r>
+            <a:r>
+              <a:rPr sz="1600" b="0" i="0" baseline="30000">
+                <a:solidFill>
+                  <a:srgbClr val="0B3D5C"/>
+                </a:solidFill>
+                <a:latin typeface="Cambria Math"/>
+              </a:rPr>
+              <a:t>2</a:t>
+            </a:r>
+            <a:r>
+              <a:rPr sz="1600" b="0" i="0">
+                <a:solidFill>
+                  <a:srgbClr val="0B3D5C"/>
+                </a:solidFill>
+                <a:latin typeface="Cambria Math"/>
+              </a:rPr>
+              <a:t> φ</a:t>
+            </a:r>
+            <a:r>
+              <a:rPr sz="1600" b="0" i="0" baseline="-25000">
+                <a:solidFill>
+                  <a:srgbClr val="0B3D5C"/>
+                </a:solidFill>
+                <a:latin typeface="Cambria Math"/>
+              </a:rPr>
+              <a:t>2</a:t>
+            </a:r>
+            <a:r>
+              <a:rPr sz="1600" b="0" i="0" baseline="30000">
+                <a:solidFill>
+                  <a:srgbClr val="0B3D5C"/>
+                </a:solidFill>
+                <a:latin typeface="Cambria Math"/>
+              </a:rPr>
+              <a:t>2</a:t>
+            </a:r>
+          </a:p>
           <a:p>
             <a:pPr algn="l">
               <a:spcBef>
                 <a:spcPts val="0"/>
               </a:spcBef>
               <a:spcAft>
-                <a:spcPts val="400"/>
+                <a:spcPts val="1200"/>
               </a:spcAft>
             </a:pPr>
             <a:r>
-              <a:rPr sz="1600" b="1" i="0">
-                <a:solidFill>
-                  <a:srgbClr val="0B3D5C"/>
+              <a:rPr sz="1300" b="0" i="0">
+                <a:solidFill>
+                  <a:srgbClr val="1F2937"/>
                 </a:solidFill>
                 <a:latin typeface="Calibri"/>
               </a:rPr>
-              <a:t>Planar morphology is controlled mainly by polarization anchoring.</a:t>
+              <a:t>Costs energy only where both cells' φ are simultaneously ≈ 1 — i.e. right at contact. Adds one line, 2kᵣₑₚφᵢφⱼ², to each cell's own μᵢ. Everything else — the Darcy law, the P equation — is untouched: still local, still no global solve.</a:t>
             </a:r>
           </a:p>
           <a:p>
@@ -15054,470 +16107,79 @@
               </a:spcAft>
             </a:pPr>
             <a:r>
-              <a:rPr sz="1250" b="0" i="0">
-                <a:solidFill>
-                  <a:srgbClr val="4B5563"/>
+              <a:rPr sz="1500" b="1" i="0">
+                <a:solidFill>
+                  <a:srgbClr val="1A7A6D"/>
                 </a:solidFill>
                 <a:latin typeface="Calibri"/>
               </a:rPr>
-              <a:t>V3  ·  flow adds ~2%</a:t>
-            </a:r>
-          </a:p>
-        </p:txBody>
-      </p:sp>
-      <p:sp>
-        <p:nvSpPr>
-          <p:cNvPr id="17" name="Rounded Rectangle 16"/>
-          <p:cNvSpPr/>
-          <p:nvPr/>
-        </p:nvSpPr>
-        <p:spPr>
-          <a:xfrm>
-            <a:off x="365760" y="3209544"/>
-            <a:ext cx="11430000" cy="969264"/>
-          </a:xfrm>
-          <a:prstGeom prst="roundRect">
-            <a:avLst>
-              <a:gd name="adj" fmla="val 8000"/>
-            </a:avLst>
-          </a:prstGeom>
-          <a:solidFill>
-            <a:srgbClr val="F3F6F9"/>
-          </a:solidFill>
-          <a:ln>
-            <a:noFill/>
-          </a:ln>
-          <a:effectLst/>
-        </p:spPr>
-        <p:style>
-          <a:lnRef idx="1">
-            <a:schemeClr val="accent1"/>
-          </a:lnRef>
-          <a:fillRef idx="3">
-            <a:schemeClr val="accent1"/>
-          </a:fillRef>
-          <a:effectRef idx="2">
-            <a:schemeClr val="accent1"/>
-          </a:effectRef>
-          <a:fontRef idx="minor">
-            <a:schemeClr val="lt1"/>
-          </a:fontRef>
-        </p:style>
-        <p:txBody>
-          <a:bodyPr rtlCol="0" anchor="ctr"/>
-          <a:lstStyle/>
-          <a:p>
-            <a:pPr algn="ctr"/>
-          </a:p>
-        </p:txBody>
-      </p:sp>
-      <p:sp>
-        <p:nvSpPr>
-          <p:cNvPr id="18" name="Rectangle 17"/>
-          <p:cNvSpPr/>
-          <p:nvPr/>
-        </p:nvSpPr>
-        <p:spPr>
-          <a:xfrm>
-            <a:off x="365760" y="3209544"/>
-            <a:ext cx="109728" cy="969264"/>
-          </a:xfrm>
-          <a:prstGeom prst="rect">
-            <a:avLst/>
-          </a:prstGeom>
-          <a:solidFill>
-            <a:srgbClr val="1A7A6D"/>
-          </a:solidFill>
-          <a:ln>
-            <a:noFill/>
-          </a:ln>
-          <a:effectLst/>
-        </p:spPr>
-        <p:style>
-          <a:lnRef idx="1">
-            <a:schemeClr val="accent1"/>
-          </a:lnRef>
-          <a:fillRef idx="3">
-            <a:schemeClr val="accent1"/>
-          </a:fillRef>
-          <a:effectRef idx="2">
-            <a:schemeClr val="accent1"/>
-          </a:effectRef>
-          <a:fontRef idx="minor">
-            <a:schemeClr val="lt1"/>
-          </a:fontRef>
-        </p:style>
-        <p:txBody>
-          <a:bodyPr rtlCol="0" anchor="ctr"/>
-          <a:lstStyle/>
-          <a:p>
-            <a:pPr algn="ctr"/>
-          </a:p>
-        </p:txBody>
-      </p:sp>
-      <p:sp>
-        <p:nvSpPr>
-          <p:cNvPr id="19" name="TextBox 18"/>
-          <p:cNvSpPr txBox="1"/>
-          <p:nvPr/>
-        </p:nvSpPr>
-        <p:spPr>
-          <a:xfrm>
-            <a:off x="594360" y="3264408"/>
-            <a:ext cx="640080" cy="822960"/>
-          </a:xfrm>
-          <a:prstGeom prst="rect">
-            <a:avLst/>
-          </a:prstGeom>
-          <a:noFill/>
-        </p:spPr>
-        <p:txBody>
-          <a:bodyPr wrap="square" lIns="54864" rIns="54864" tIns="27432" bIns="18288">
-            <a:spAutoFit/>
-          </a:bodyPr>
-          <a:lstStyle/>
-          <a:p>
-            <a:pPr algn="l">
-              <a:spcBef>
-                <a:spcPts val="0"/>
-              </a:spcBef>
-              <a:spcAft>
-                <a:spcPts val="0"/>
-              </a:spcAft>
-            </a:pPr>
-            <a:r>
-              <a:rPr sz="2200" b="1" i="0">
-                <a:solidFill>
-                  <a:srgbClr val="1A7A6D"/>
-                </a:solidFill>
-                <a:latin typeface="Calibri"/>
-              </a:rPr>
-              <a:t>03</a:t>
-            </a:r>
-          </a:p>
-        </p:txBody>
-      </p:sp>
-      <p:sp>
-        <p:nvSpPr>
-          <p:cNvPr id="20" name="TextBox 19"/>
-          <p:cNvSpPr txBox="1"/>
-          <p:nvPr/>
-        </p:nvSpPr>
-        <p:spPr>
-          <a:xfrm>
-            <a:off x="1280160" y="3282696"/>
-            <a:ext cx="10287000" cy="822960"/>
-          </a:xfrm>
-          <a:prstGeom prst="rect">
-            <a:avLst/>
-          </a:prstGeom>
-          <a:noFill/>
-        </p:spPr>
-        <p:txBody>
-          <a:bodyPr wrap="square" lIns="54864" rIns="54864" tIns="27432" bIns="18288">
-            <a:spAutoFit/>
-          </a:bodyPr>
-          <a:lstStyle/>
-          <a:p>
-            <a:pPr algn="l">
-              <a:spcBef>
-                <a:spcPts val="0"/>
-              </a:spcBef>
+              <a:t>First experiment: a glancing collision</a:t>
+            </a:r>
+          </a:p>
+          <a:p>
+            <a:pPr>
               <a:spcAft>
                 <a:spcPts val="400"/>
               </a:spcAft>
             </a:pPr>
             <a:r>
-              <a:rPr sz="1600" b="1" i="0">
-                <a:solidFill>
-                  <a:srgbClr val="0B3D5C"/>
+              <a:rPr sz="1250" b="0" i="0">
+                <a:solidFill>
+                  <a:srgbClr val="1F2937"/>
                 </a:solidFill>
                 <a:latin typeface="Calibri"/>
               </a:rPr>
-              <a:t>The friction-dominated model retains crawling behaviour.</a:t>
-            </a:r>
-          </a:p>
-          <a:p>
-            <a:pPr algn="l">
-              <a:spcBef>
-                <a:spcPts val="0"/>
-              </a:spcBef>
-              <a:spcAft>
-                <a:spcPts val="600"/>
-              </a:spcAft>
-            </a:pPr>
-            <a:r>
-              <a:rPr sz="1250" b="0" i="0">
-                <a:solidFill>
-                  <a:srgbClr val="4B5563"/>
-                </a:solidFill>
-                <a:latin typeface="Calibri"/>
-              </a:rPr>
-              <a:t>V4  ·  speed 0.801  ·  0.2% agreement  ·  ~5× faster  ·  local</a:t>
-            </a:r>
-          </a:p>
-        </p:txBody>
-      </p:sp>
-      <p:sp>
-        <p:nvSpPr>
-          <p:cNvPr id="21" name="Rounded Rectangle 20"/>
-          <p:cNvSpPr/>
-          <p:nvPr/>
-        </p:nvSpPr>
-        <p:spPr>
-          <a:xfrm>
-            <a:off x="365760" y="4288536"/>
-            <a:ext cx="11430000" cy="969264"/>
-          </a:xfrm>
-          <a:prstGeom prst="roundRect">
-            <a:avLst>
-              <a:gd name="adj" fmla="val 8000"/>
-            </a:avLst>
-          </a:prstGeom>
-          <a:solidFill>
-            <a:srgbClr val="F3F6F9"/>
-          </a:solidFill>
-          <a:ln>
-            <a:noFill/>
-          </a:ln>
-          <a:effectLst/>
-        </p:spPr>
-        <p:style>
-          <a:lnRef idx="1">
-            <a:schemeClr val="accent1"/>
-          </a:lnRef>
-          <a:fillRef idx="3">
-            <a:schemeClr val="accent1"/>
-          </a:fillRef>
-          <a:effectRef idx="2">
-            <a:schemeClr val="accent1"/>
-          </a:effectRef>
-          <a:fontRef idx="minor">
-            <a:schemeClr val="lt1"/>
-          </a:fontRef>
-        </p:style>
-        <p:txBody>
-          <a:bodyPr rtlCol="0" anchor="ctr"/>
-          <a:lstStyle/>
-          <a:p>
-            <a:pPr algn="ctr"/>
-          </a:p>
-        </p:txBody>
-      </p:sp>
-      <p:sp>
-        <p:nvSpPr>
-          <p:cNvPr id="22" name="Rectangle 21"/>
-          <p:cNvSpPr/>
-          <p:nvPr/>
-        </p:nvSpPr>
-        <p:spPr>
-          <a:xfrm>
-            <a:off x="365760" y="4288536"/>
-            <a:ext cx="109728" cy="969264"/>
-          </a:xfrm>
-          <a:prstGeom prst="rect">
-            <a:avLst/>
-          </a:prstGeom>
-          <a:solidFill>
-            <a:srgbClr val="1A7A6D"/>
-          </a:solidFill>
-          <a:ln>
-            <a:noFill/>
-          </a:ln>
-          <a:effectLst/>
-        </p:spPr>
-        <p:style>
-          <a:lnRef idx="1">
-            <a:schemeClr val="accent1"/>
-          </a:lnRef>
-          <a:fillRef idx="3">
-            <a:schemeClr val="accent1"/>
-          </a:fillRef>
-          <a:effectRef idx="2">
-            <a:schemeClr val="accent1"/>
-          </a:effectRef>
-          <a:fontRef idx="minor">
-            <a:schemeClr val="lt1"/>
-          </a:fontRef>
-        </p:style>
-        <p:txBody>
-          <a:bodyPr rtlCol="0" anchor="ctr"/>
-          <a:lstStyle/>
-          <a:p>
-            <a:pPr algn="ctr"/>
-          </a:p>
-        </p:txBody>
-      </p:sp>
-      <p:sp>
-        <p:nvSpPr>
-          <p:cNvPr id="23" name="TextBox 22"/>
-          <p:cNvSpPr txBox="1"/>
-          <p:nvPr/>
-        </p:nvSpPr>
-        <p:spPr>
-          <a:xfrm>
-            <a:off x="594360" y="4343400"/>
-            <a:ext cx="640080" cy="822960"/>
-          </a:xfrm>
-          <a:prstGeom prst="rect">
-            <a:avLst/>
-          </a:prstGeom>
-          <a:noFill/>
-        </p:spPr>
-        <p:txBody>
-          <a:bodyPr wrap="square" lIns="54864" rIns="54864" tIns="27432" bIns="18288">
-            <a:spAutoFit/>
-          </a:bodyPr>
-          <a:lstStyle/>
-          <a:p>
-            <a:pPr algn="l">
-              <a:spcBef>
-                <a:spcPts val="0"/>
-              </a:spcBef>
-              <a:spcAft>
-                <a:spcPts val="0"/>
-              </a:spcAft>
-            </a:pPr>
-            <a:r>
-              <a:rPr sz="2200" b="1" i="0">
-                <a:solidFill>
-                  <a:srgbClr val="1A7A6D"/>
-                </a:solidFill>
-                <a:latin typeface="Calibri"/>
-              </a:rPr>
-              <a:t>04</a:t>
-            </a:r>
-          </a:p>
-        </p:txBody>
-      </p:sp>
-      <p:sp>
-        <p:nvSpPr>
-          <p:cNvPr id="24" name="TextBox 23"/>
-          <p:cNvSpPr txBox="1"/>
-          <p:nvPr/>
-        </p:nvSpPr>
-        <p:spPr>
-          <a:xfrm>
-            <a:off x="1280160" y="4361688"/>
-            <a:ext cx="10287000" cy="822960"/>
-          </a:xfrm>
-          <a:prstGeom prst="rect">
-            <a:avLst/>
-          </a:prstGeom>
-          <a:noFill/>
-        </p:spPr>
-        <p:txBody>
-          <a:bodyPr wrap="square" lIns="54864" rIns="54864" tIns="27432" bIns="18288">
-            <a:spAutoFit/>
-          </a:bodyPr>
-          <a:lstStyle/>
-          <a:p>
-            <a:pPr algn="l">
-              <a:spcBef>
-                <a:spcPts val="0"/>
-              </a:spcBef>
+              <a:t>•  Cells offset in y, polarised toward each other</a:t>
+            </a:r>
+          </a:p>
+          <a:p>
+            <a:pPr>
               <a:spcAft>
                 <a:spcPts val="400"/>
               </a:spcAft>
             </a:pPr>
             <a:r>
-              <a:rPr sz="1600" b="1" i="0">
-                <a:solidFill>
-                  <a:srgbClr val="0B3D5C"/>
+              <a:rPr sz="1250" b="0" i="0">
+                <a:solidFill>
+                  <a:srgbClr val="1F2937"/>
                 </a:solidFill>
                 <a:latin typeface="Calibri"/>
               </a:rPr>
-              <a:t>Volume conservation is more appropriate than rigid projected-area conservation.</a:t>
-            </a:r>
-          </a:p>
-          <a:p>
-            <a:pPr algn="l">
-              <a:spcBef>
-                <a:spcPts val="0"/>
-              </a:spcBef>
+              <a:t>•  Approach → brief contact → clean scatter apart</a:t>
+            </a:r>
+          </a:p>
+          <a:p>
+            <a:pPr>
               <a:spcAft>
-                <a:spcPts val="600"/>
+                <a:spcPts val="400"/>
               </a:spcAft>
             </a:pPr>
             <a:r>
               <a:rPr sz="1250" b="0" i="0">
                 <a:solidFill>
-                  <a:srgbClr val="4B5563"/>
+                  <a:srgbClr val="1F2937"/>
                 </a:solidFill>
                 <a:latin typeface="Calibri"/>
               </a:rPr>
-              <a:t>kₐ = 5: area +15%      kₐ = 0: inflation, crawling lost</a:t>
-            </a:r>
-          </a:p>
-        </p:txBody>
-      </p:sp>
-      <p:sp>
-        <p:nvSpPr>
-          <p:cNvPr id="25" name="Rounded Rectangle 24"/>
-          <p:cNvSpPr/>
-          <p:nvPr/>
-        </p:nvSpPr>
-        <p:spPr>
-          <a:xfrm>
-            <a:off x="365760" y="5468112"/>
-            <a:ext cx="11430000" cy="960120"/>
-          </a:xfrm>
-          <a:prstGeom prst="roundRect">
-            <a:avLst>
-              <a:gd name="adj" fmla="val 8000"/>
-            </a:avLst>
-          </a:prstGeom>
-          <a:solidFill>
-            <a:srgbClr val="0B3D5C"/>
-          </a:solidFill>
-          <a:ln>
-            <a:noFill/>
-          </a:ln>
-          <a:effectLst/>
-        </p:spPr>
-        <p:style>
-          <a:lnRef idx="1">
-            <a:schemeClr val="accent1"/>
-          </a:lnRef>
-          <a:fillRef idx="3">
-            <a:schemeClr val="accent1"/>
-          </a:fillRef>
-          <a:effectRef idx="2">
-            <a:schemeClr val="accent1"/>
-          </a:effectRef>
-          <a:fontRef idx="minor">
-            <a:schemeClr val="lt1"/>
-          </a:fontRef>
-        </p:style>
-        <p:txBody>
-          <a:bodyPr rtlCol="0" anchor="ctr"/>
-          <a:lstStyle/>
-          <a:p>
-            <a:pPr algn="ctr"/>
-          </a:p>
-        </p:txBody>
-      </p:sp>
-      <p:sp>
-        <p:nvSpPr>
-          <p:cNvPr id="26" name="TextBox 25"/>
-          <p:cNvSpPr txBox="1"/>
-          <p:nvPr/>
-        </p:nvSpPr>
-        <p:spPr>
-          <a:xfrm>
-            <a:off x="548640" y="5577840"/>
-            <a:ext cx="11064240" cy="777240"/>
-          </a:xfrm>
-          <a:prstGeom prst="rect">
-            <a:avLst/>
-          </a:prstGeom>
-          <a:noFill/>
-        </p:spPr>
-        <p:txBody>
-          <a:bodyPr wrap="square" lIns="54864" rIns="54864" tIns="27432" bIns="18288">
-            <a:spAutoFit/>
-          </a:bodyPr>
-          <a:lstStyle/>
+              <a:t>•  Contact overlap peaks at 2.1, well under the 8.7 a non-interacting pair would show at nominal touching</a:t>
+            </a:r>
+          </a:p>
+          <a:p>
+            <a:pPr>
+              <a:spcAft>
+                <a:spcPts val="1000"/>
+              </a:spcAft>
+            </a:pPr>
+            <a:r>
+              <a:rPr sz="1250" b="0" i="0">
+                <a:solidFill>
+                  <a:srgbClr val="1F2937"/>
+                </a:solidFill>
+                <a:latin typeface="Calibri"/>
+              </a:rPr>
+              <a:t>•  No merging, no numerical blow-up, healthy interiors throughout</a:t>
+            </a:r>
+          </a:p>
           <a:p>
             <a:pPr algn="l">
               <a:lnSpc>
@@ -15531,13 +16193,13 @@
               </a:spcAft>
             </a:pPr>
             <a:r>
-              <a:rPr sz="1600" b="1" i="0">
-                <a:solidFill>
-                  <a:srgbClr val="FFFFFF"/>
+              <a:rPr sz="1200" b="0" i="0">
+                <a:solidFill>
+                  <a:srgbClr val="4B5563"/>
                 </a:solidFill>
                 <a:latin typeface="Calibri"/>
               </a:rPr>
-              <a:t>Take-home: a verified local single-cell model now reproduces crawling without a global Stokes solve — providing a computational base for many-cell simulations.</a:t>
+              <a:t>Head-on collisions (both cells pointed straight at each other) are a harder, still-open case — noted honestly, not hidden.</a:t>
             </a:r>
           </a:p>
         </p:txBody>
@@ -15547,6 +16209,28 @@
   <p:clrMapOvr>
     <a:masterClrMapping/>
   </p:clrMapOvr>
+  <p:timing>
+    <p:tnLst>
+      <p:par>
+        <p:cTn id="1" dur="indefinite" restart="never" nodeType="tmRoot">
+          <p:childTnLst>
+            <p:video>
+              <p:cMediaNode vol="80000">
+                <p:cTn id="2" fill="hold" display="0">
+                  <p:stCondLst>
+                    <p:cond delay="indefinite"/>
+                  </p:stCondLst>
+                </p:cTn>
+                <p:tgtEl>
+                  <p:spTgt spid="10"/>
+                </p:tgtEl>
+              </p:cMediaNode>
+            </p:video>
+          </p:childTnLst>
+        </p:cTn>
+      </p:par>
+    </p:tnLst>
+  </p:timing>
 </p:sld>
 </file>
 
@@ -15729,7 +16413,7 @@
                 </a:solidFill>
                 <a:latin typeface="Calibri"/>
               </a:rPr>
-              <a:t>From one cell to many</a:t>
+              <a:t>What the simulations establish</a:t>
             </a:r>
           </a:p>
         </p:txBody>
@@ -15857,7 +16541,7 @@
                 </a:solidFill>
                 <a:latin typeface="Calibri"/>
               </a:rPr>
-              <a:t>9 / 9</a:t>
+              <a:t>9 / 10</a:t>
             </a:r>
           </a:p>
         </p:txBody>
@@ -15870,8 +16554,8 @@
         </p:nvSpPr>
         <p:spPr>
           <a:xfrm>
-            <a:off x="292608" y="1051560"/>
-            <a:ext cx="2267712" cy="2148840"/>
+            <a:off x="365760" y="1051560"/>
+            <a:ext cx="11430000" cy="969264"/>
           </a:xfrm>
           <a:prstGeom prst="roundRect">
             <a:avLst>
@@ -15910,14 +16594,58 @@
       </p:sp>
       <p:sp>
         <p:nvSpPr>
-          <p:cNvPr id="10" name="TextBox 9"/>
+          <p:cNvPr id="10" name="Rectangle 9"/>
+          <p:cNvSpPr/>
+          <p:nvPr/>
+        </p:nvSpPr>
+        <p:spPr>
+          <a:xfrm>
+            <a:off x="365760" y="1051560"/>
+            <a:ext cx="109728" cy="969264"/>
+          </a:xfrm>
+          <a:prstGeom prst="rect">
+            <a:avLst/>
+          </a:prstGeom>
+          <a:solidFill>
+            <a:srgbClr val="1A7A6D"/>
+          </a:solidFill>
+          <a:ln>
+            <a:noFill/>
+          </a:ln>
+          <a:effectLst/>
+        </p:spPr>
+        <p:style>
+          <a:lnRef idx="1">
+            <a:schemeClr val="accent1"/>
+          </a:lnRef>
+          <a:fillRef idx="3">
+            <a:schemeClr val="accent1"/>
+          </a:fillRef>
+          <a:effectRef idx="2">
+            <a:schemeClr val="accent1"/>
+          </a:effectRef>
+          <a:fontRef idx="minor">
+            <a:schemeClr val="lt1"/>
+          </a:fontRef>
+        </p:style>
+        <p:txBody>
+          <a:bodyPr rtlCol="0" anchor="ctr"/>
+          <a:lstStyle/>
+          <a:p>
+            <a:pPr algn="ctr"/>
+          </a:p>
+        </p:txBody>
+      </p:sp>
+      <p:sp>
+        <p:nvSpPr>
+          <p:cNvPr id="11" name="TextBox 10"/>
           <p:cNvSpPr txBox="1"/>
           <p:nvPr/>
         </p:nvSpPr>
         <p:spPr>
           <a:xfrm>
-            <a:off x="384048" y="1143000"/>
-            <a:ext cx="2084831" cy="1965960"/>
+            <a:off x="594360" y="1106424"/>
+            <a:ext cx="640080" cy="822960"/>
           </a:xfrm>
           <a:prstGeom prst="rect">
             <a:avLst/>
@@ -15935,17 +16663,59 @@
                 <a:spcPts val="0"/>
               </a:spcBef>
               <a:spcAft>
-                <a:spcPts val="800"/>
+                <a:spcPts val="0"/>
               </a:spcAft>
             </a:pPr>
             <a:r>
+              <a:rPr sz="2200" b="1" i="0">
+                <a:solidFill>
+                  <a:srgbClr val="1A7A6D"/>
+                </a:solidFill>
+                <a:latin typeface="Calibri"/>
+              </a:rPr>
+              <a:t>01</a:t>
+            </a:r>
+          </a:p>
+        </p:txBody>
+      </p:sp>
+      <p:sp>
+        <p:nvSpPr>
+          <p:cNvPr id="12" name="TextBox 11"/>
+          <p:cNvSpPr txBox="1"/>
+          <p:nvPr/>
+        </p:nvSpPr>
+        <p:spPr>
+          <a:xfrm>
+            <a:off x="1280160" y="1124712"/>
+            <a:ext cx="10287000" cy="822960"/>
+          </a:xfrm>
+          <a:prstGeom prst="rect">
+            <a:avLst/>
+          </a:prstGeom>
+          <a:noFill/>
+        </p:spPr>
+        <p:txBody>
+          <a:bodyPr wrap="square" lIns="54864" rIns="54864" tIns="27432" bIns="18288">
+            <a:spAutoFit/>
+          </a:bodyPr>
+          <a:lstStyle/>
+          <a:p>
+            <a:pPr algn="l">
+              <a:spcBef>
+                <a:spcPts val="0"/>
+              </a:spcBef>
+              <a:spcAft>
+                <a:spcPts val="400"/>
+              </a:spcAft>
+            </a:pPr>
+            <a:r>
               <a:rPr sz="1600" b="1" i="0">
                 <a:solidFill>
-                  <a:srgbClr val="1A7A6D"/>
+                  <a:srgbClr val="0B3D5C"/>
                 </a:solidFill>
                 <a:latin typeface="Calibri"/>
               </a:rPr>
-              <a:t>1  Two cells</a:t>
+              <a:t>A spatial gradient in treadmilling can generate a leading protrusion.</a:t>
             </a:r>
           </a:p>
           <a:p>
@@ -15960,25 +16730,25 @@
             <a:r>
               <a:rPr sz="1250" b="0" i="0">
                 <a:solidFill>
-                  <a:srgbClr val="1F2937"/>
+                  <a:srgbClr val="4B5563"/>
                 </a:solidFill>
                 <a:latin typeface="Calibri"/>
               </a:rPr>
-              <a:t>One field pair per cell + repulsive overlap.</a:t>
-            </a:r>
-          </a:p>
-        </p:txBody>
-      </p:sp>
-      <p:sp>
-        <p:nvSpPr>
-          <p:cNvPr id="11" name="Rounded Rectangle 10"/>
+              <a:t>V2</a:t>
+            </a:r>
+          </a:p>
+        </p:txBody>
+      </p:sp>
+      <p:sp>
+        <p:nvSpPr>
+          <p:cNvPr id="13" name="Rounded Rectangle 12"/>
           <p:cNvSpPr/>
           <p:nvPr/>
         </p:nvSpPr>
         <p:spPr>
           <a:xfrm>
-            <a:off x="2651760" y="1051560"/>
-            <a:ext cx="2267712" cy="2148840"/>
+            <a:off x="365760" y="2130552"/>
+            <a:ext cx="11430000" cy="969264"/>
           </a:xfrm>
           <a:prstGeom prst="roundRect">
             <a:avLst>
@@ -16017,14 +16787,58 @@
       </p:sp>
       <p:sp>
         <p:nvSpPr>
-          <p:cNvPr id="12" name="TextBox 11"/>
+          <p:cNvPr id="14" name="Rectangle 13"/>
+          <p:cNvSpPr/>
+          <p:nvPr/>
+        </p:nvSpPr>
+        <p:spPr>
+          <a:xfrm>
+            <a:off x="365760" y="2130552"/>
+            <a:ext cx="109728" cy="969264"/>
+          </a:xfrm>
+          <a:prstGeom prst="rect">
+            <a:avLst/>
+          </a:prstGeom>
+          <a:solidFill>
+            <a:srgbClr val="1A7A6D"/>
+          </a:solidFill>
+          <a:ln>
+            <a:noFill/>
+          </a:ln>
+          <a:effectLst/>
+        </p:spPr>
+        <p:style>
+          <a:lnRef idx="1">
+            <a:schemeClr val="accent1"/>
+          </a:lnRef>
+          <a:fillRef idx="3">
+            <a:schemeClr val="accent1"/>
+          </a:fillRef>
+          <a:effectRef idx="2">
+            <a:schemeClr val="accent1"/>
+          </a:effectRef>
+          <a:fontRef idx="minor">
+            <a:schemeClr val="lt1"/>
+          </a:fontRef>
+        </p:style>
+        <p:txBody>
+          <a:bodyPr rtlCol="0" anchor="ctr"/>
+          <a:lstStyle/>
+          <a:p>
+            <a:pPr algn="ctr"/>
+          </a:p>
+        </p:txBody>
+      </p:sp>
+      <p:sp>
+        <p:nvSpPr>
+          <p:cNvPr id="15" name="TextBox 14"/>
           <p:cNvSpPr txBox="1"/>
           <p:nvPr/>
         </p:nvSpPr>
         <p:spPr>
           <a:xfrm>
-            <a:off x="2743200" y="1143000"/>
-            <a:ext cx="2084831" cy="1965960"/>
+            <a:off x="594360" y="2185416"/>
+            <a:ext cx="640080" cy="822960"/>
           </a:xfrm>
           <a:prstGeom prst="rect">
             <a:avLst/>
@@ -16042,17 +16856,59 @@
                 <a:spcPts val="0"/>
               </a:spcBef>
               <a:spcAft>
-                <a:spcPts val="800"/>
+                <a:spcPts val="0"/>
               </a:spcAft>
             </a:pPr>
             <a:r>
+              <a:rPr sz="2200" b="1" i="0">
+                <a:solidFill>
+                  <a:srgbClr val="1A7A6D"/>
+                </a:solidFill>
+                <a:latin typeface="Calibri"/>
+              </a:rPr>
+              <a:t>02</a:t>
+            </a:r>
+          </a:p>
+        </p:txBody>
+      </p:sp>
+      <p:sp>
+        <p:nvSpPr>
+          <p:cNvPr id="16" name="TextBox 15"/>
+          <p:cNvSpPr txBox="1"/>
+          <p:nvPr/>
+        </p:nvSpPr>
+        <p:spPr>
+          <a:xfrm>
+            <a:off x="1280160" y="2203704"/>
+            <a:ext cx="10287000" cy="822960"/>
+          </a:xfrm>
+          <a:prstGeom prst="rect">
+            <a:avLst/>
+          </a:prstGeom>
+          <a:noFill/>
+        </p:spPr>
+        <p:txBody>
+          <a:bodyPr wrap="square" lIns="54864" rIns="54864" tIns="27432" bIns="18288">
+            <a:spAutoFit/>
+          </a:bodyPr>
+          <a:lstStyle/>
+          <a:p>
+            <a:pPr algn="l">
+              <a:spcBef>
+                <a:spcPts val="0"/>
+              </a:spcBef>
+              <a:spcAft>
+                <a:spcPts val="400"/>
+              </a:spcAft>
+            </a:pPr>
+            <a:r>
               <a:rPr sz="1600" b="1" i="0">
                 <a:solidFill>
-                  <a:srgbClr val="1A7A6D"/>
+                  <a:srgbClr val="0B3D5C"/>
                 </a:solidFill>
                 <a:latin typeface="Calibri"/>
               </a:rPr>
-              <a:t>2  Collisions</a:t>
+              <a:t>Planar morphology is controlled mainly by polarization anchoring.</a:t>
             </a:r>
           </a:p>
           <a:p>
@@ -16067,25 +16923,25 @@
             <a:r>
               <a:rPr sz="1250" b="0" i="0">
                 <a:solidFill>
-                  <a:srgbClr val="1F2937"/>
+                  <a:srgbClr val="4B5563"/>
                 </a:solidFill>
                 <a:latin typeface="Calibri"/>
               </a:rPr>
-              <a:t>Head-on and glancing interactions.</a:t>
-            </a:r>
-          </a:p>
-        </p:txBody>
-      </p:sp>
-      <p:sp>
-        <p:nvSpPr>
-          <p:cNvPr id="13" name="Rounded Rectangle 12"/>
+              <a:t>V3  ·  flow adds ~2%</a:t>
+            </a:r>
+          </a:p>
+        </p:txBody>
+      </p:sp>
+      <p:sp>
+        <p:nvSpPr>
+          <p:cNvPr id="17" name="Rounded Rectangle 16"/>
           <p:cNvSpPr/>
           <p:nvPr/>
         </p:nvSpPr>
         <p:spPr>
           <a:xfrm>
-            <a:off x="5010912" y="1051560"/>
-            <a:ext cx="2267712" cy="2148840"/>
+            <a:off x="365760" y="3209544"/>
+            <a:ext cx="11430000" cy="969264"/>
           </a:xfrm>
           <a:prstGeom prst="roundRect">
             <a:avLst>
@@ -16124,14 +16980,58 @@
       </p:sp>
       <p:sp>
         <p:nvSpPr>
-          <p:cNvPr id="14" name="TextBox 13"/>
+          <p:cNvPr id="18" name="Rectangle 17"/>
+          <p:cNvSpPr/>
+          <p:nvPr/>
+        </p:nvSpPr>
+        <p:spPr>
+          <a:xfrm>
+            <a:off x="365760" y="3209544"/>
+            <a:ext cx="109728" cy="969264"/>
+          </a:xfrm>
+          <a:prstGeom prst="rect">
+            <a:avLst/>
+          </a:prstGeom>
+          <a:solidFill>
+            <a:srgbClr val="1A7A6D"/>
+          </a:solidFill>
+          <a:ln>
+            <a:noFill/>
+          </a:ln>
+          <a:effectLst/>
+        </p:spPr>
+        <p:style>
+          <a:lnRef idx="1">
+            <a:schemeClr val="accent1"/>
+          </a:lnRef>
+          <a:fillRef idx="3">
+            <a:schemeClr val="accent1"/>
+          </a:fillRef>
+          <a:effectRef idx="2">
+            <a:schemeClr val="accent1"/>
+          </a:effectRef>
+          <a:fontRef idx="minor">
+            <a:schemeClr val="lt1"/>
+          </a:fontRef>
+        </p:style>
+        <p:txBody>
+          <a:bodyPr rtlCol="0" anchor="ctr"/>
+          <a:lstStyle/>
+          <a:p>
+            <a:pPr algn="ctr"/>
+          </a:p>
+        </p:txBody>
+      </p:sp>
+      <p:sp>
+        <p:nvSpPr>
+          <p:cNvPr id="19" name="TextBox 18"/>
           <p:cNvSpPr txBox="1"/>
           <p:nvPr/>
         </p:nvSpPr>
         <p:spPr>
           <a:xfrm>
-            <a:off x="5102352" y="1143000"/>
-            <a:ext cx="2084831" cy="1965960"/>
+            <a:off x="594360" y="3264408"/>
+            <a:ext cx="640080" cy="822960"/>
           </a:xfrm>
           <a:prstGeom prst="rect">
             <a:avLst/>
@@ -16149,17 +17049,59 @@
                 <a:spcPts val="0"/>
               </a:spcBef>
               <a:spcAft>
-                <a:spcPts val="800"/>
+                <a:spcPts val="0"/>
               </a:spcAft>
             </a:pPr>
             <a:r>
+              <a:rPr sz="2200" b="1" i="0">
+                <a:solidFill>
+                  <a:srgbClr val="1A7A6D"/>
+                </a:solidFill>
+                <a:latin typeface="Calibri"/>
+              </a:rPr>
+              <a:t>03</a:t>
+            </a:r>
+          </a:p>
+        </p:txBody>
+      </p:sp>
+      <p:sp>
+        <p:nvSpPr>
+          <p:cNvPr id="20" name="TextBox 19"/>
+          <p:cNvSpPr txBox="1"/>
+          <p:nvPr/>
+        </p:nvSpPr>
+        <p:spPr>
+          <a:xfrm>
+            <a:off x="1280160" y="3282696"/>
+            <a:ext cx="10287000" cy="822960"/>
+          </a:xfrm>
+          <a:prstGeom prst="rect">
+            <a:avLst/>
+          </a:prstGeom>
+          <a:noFill/>
+        </p:spPr>
+        <p:txBody>
+          <a:bodyPr wrap="square" lIns="54864" rIns="54864" tIns="27432" bIns="18288">
+            <a:spAutoFit/>
+          </a:bodyPr>
+          <a:lstStyle/>
+          <a:p>
+            <a:pPr algn="l">
+              <a:spcBef>
+                <a:spcPts val="0"/>
+              </a:spcBef>
+              <a:spcAft>
+                <a:spcPts val="400"/>
+              </a:spcAft>
+            </a:pPr>
+            <a:r>
               <a:rPr sz="1600" b="1" i="0">
                 <a:solidFill>
-                  <a:srgbClr val="1A7A6D"/>
+                  <a:srgbClr val="0B3D5C"/>
                 </a:solidFill>
                 <a:latin typeface="Calibri"/>
               </a:rPr>
-              <a:t>3  Polarity</a:t>
+              <a:t>The friction-dominated model retains crawling behaviour.</a:t>
             </a:r>
           </a:p>
           <a:p>
@@ -16174,25 +17116,25 @@
             <a:r>
               <a:rPr sz="1250" b="0" i="0">
                 <a:solidFill>
-                  <a:srgbClr val="1F2937"/>
+                  <a:srgbClr val="4B5563"/>
                 </a:solidFill>
                 <a:latin typeface="Calibri"/>
               </a:rPr>
-              <a:t>Allow cells to choose their own direction.</a:t>
-            </a:r>
-          </a:p>
-        </p:txBody>
-      </p:sp>
-      <p:sp>
-        <p:nvSpPr>
-          <p:cNvPr id="15" name="Rounded Rectangle 14"/>
+              <a:t>V4  ·  speed 0.801  ·  0.2% agreement  ·  ~5× faster  ·  local</a:t>
+            </a:r>
+          </a:p>
+        </p:txBody>
+      </p:sp>
+      <p:sp>
+        <p:nvSpPr>
+          <p:cNvPr id="21" name="Rounded Rectangle 20"/>
           <p:cNvSpPr/>
           <p:nvPr/>
         </p:nvSpPr>
         <p:spPr>
           <a:xfrm>
-            <a:off x="7370064" y="1051560"/>
-            <a:ext cx="2267712" cy="2148840"/>
+            <a:off x="365760" y="4288536"/>
+            <a:ext cx="11430000" cy="969264"/>
           </a:xfrm>
           <a:prstGeom prst="roundRect">
             <a:avLst>
@@ -16231,14 +17173,58 @@
       </p:sp>
       <p:sp>
         <p:nvSpPr>
-          <p:cNvPr id="16" name="TextBox 15"/>
+          <p:cNvPr id="22" name="Rectangle 21"/>
+          <p:cNvSpPr/>
+          <p:nvPr/>
+        </p:nvSpPr>
+        <p:spPr>
+          <a:xfrm>
+            <a:off x="365760" y="4288536"/>
+            <a:ext cx="109728" cy="969264"/>
+          </a:xfrm>
+          <a:prstGeom prst="rect">
+            <a:avLst/>
+          </a:prstGeom>
+          <a:solidFill>
+            <a:srgbClr val="1A7A6D"/>
+          </a:solidFill>
+          <a:ln>
+            <a:noFill/>
+          </a:ln>
+          <a:effectLst/>
+        </p:spPr>
+        <p:style>
+          <a:lnRef idx="1">
+            <a:schemeClr val="accent1"/>
+          </a:lnRef>
+          <a:fillRef idx="3">
+            <a:schemeClr val="accent1"/>
+          </a:fillRef>
+          <a:effectRef idx="2">
+            <a:schemeClr val="accent1"/>
+          </a:effectRef>
+          <a:fontRef idx="minor">
+            <a:schemeClr val="lt1"/>
+          </a:fontRef>
+        </p:style>
+        <p:txBody>
+          <a:bodyPr rtlCol="0" anchor="ctr"/>
+          <a:lstStyle/>
+          <a:p>
+            <a:pPr algn="ctr"/>
+          </a:p>
+        </p:txBody>
+      </p:sp>
+      <p:sp>
+        <p:nvSpPr>
+          <p:cNvPr id="23" name="TextBox 22"/>
           <p:cNvSpPr txBox="1"/>
           <p:nvPr/>
         </p:nvSpPr>
         <p:spPr>
           <a:xfrm>
-            <a:off x="7461504" y="1143000"/>
-            <a:ext cx="2084831" cy="1965960"/>
+            <a:off x="594360" y="4343400"/>
+            <a:ext cx="640080" cy="822960"/>
           </a:xfrm>
           <a:prstGeom prst="rect">
             <a:avLst/>
@@ -16256,17 +17242,59 @@
                 <a:spcPts val="0"/>
               </a:spcBef>
               <a:spcAft>
-                <a:spcPts val="800"/>
+                <a:spcPts val="0"/>
               </a:spcAft>
             </a:pPr>
             <a:r>
+              <a:rPr sz="2200" b="1" i="0">
+                <a:solidFill>
+                  <a:srgbClr val="1A7A6D"/>
+                </a:solidFill>
+                <a:latin typeface="Calibri"/>
+              </a:rPr>
+              <a:t>04</a:t>
+            </a:r>
+          </a:p>
+        </p:txBody>
+      </p:sp>
+      <p:sp>
+        <p:nvSpPr>
+          <p:cNvPr id="24" name="TextBox 23"/>
+          <p:cNvSpPr txBox="1"/>
+          <p:nvPr/>
+        </p:nvSpPr>
+        <p:spPr>
+          <a:xfrm>
+            <a:off x="1280160" y="4361688"/>
+            <a:ext cx="10287000" cy="822960"/>
+          </a:xfrm>
+          <a:prstGeom prst="rect">
+            <a:avLst/>
+          </a:prstGeom>
+          <a:noFill/>
+        </p:spPr>
+        <p:txBody>
+          <a:bodyPr wrap="square" lIns="54864" rIns="54864" tIns="27432" bIns="18288">
+            <a:spAutoFit/>
+          </a:bodyPr>
+          <a:lstStyle/>
+          <a:p>
+            <a:pPr algn="l">
+              <a:spcBef>
+                <a:spcPts val="0"/>
+              </a:spcBef>
+              <a:spcAft>
+                <a:spcPts val="400"/>
+              </a:spcAft>
+            </a:pPr>
+            <a:r>
               <a:rPr sz="1600" b="1" i="0">
                 <a:solidFill>
-                  <a:srgbClr val="1A7A6D"/>
+                  <a:srgbClr val="0B3D5C"/>
                 </a:solidFill>
                 <a:latin typeface="Calibri"/>
               </a:rPr>
-              <a:t>4  Adhesion</a:t>
+              <a:t>Volume conservation is more appropriate than rigid projected-area conservation.</a:t>
             </a:r>
           </a:p>
           <a:p>
@@ -16281,132 +17309,25 @@
             <a:r>
               <a:rPr sz="1250" b="0" i="0">
                 <a:solidFill>
-                  <a:srgbClr val="1F2937"/>
+                  <a:srgbClr val="4B5563"/>
                 </a:solidFill>
                 <a:latin typeface="Calibri"/>
               </a:rPr>
-              <a:t>Load-dependent friction ξ.</a:t>
-            </a:r>
-          </a:p>
-        </p:txBody>
-      </p:sp>
-      <p:sp>
-        <p:nvSpPr>
-          <p:cNvPr id="17" name="Rounded Rectangle 16"/>
+              <a:t>kₐ = 5: area +15%      kₐ = 0: inflation, crawling lost</a:t>
+            </a:r>
+          </a:p>
+        </p:txBody>
+      </p:sp>
+      <p:sp>
+        <p:nvSpPr>
+          <p:cNvPr id="25" name="Rounded Rectangle 24"/>
           <p:cNvSpPr/>
           <p:nvPr/>
         </p:nvSpPr>
         <p:spPr>
           <a:xfrm>
-            <a:off x="9729216" y="1051560"/>
-            <a:ext cx="2267712" cy="2148840"/>
-          </a:xfrm>
-          <a:prstGeom prst="roundRect">
-            <a:avLst>
-              <a:gd name="adj" fmla="val 8000"/>
-            </a:avLst>
-          </a:prstGeom>
-          <a:solidFill>
-            <a:srgbClr val="F3F6F9"/>
-          </a:solidFill>
-          <a:ln>
-            <a:noFill/>
-          </a:ln>
-          <a:effectLst/>
-        </p:spPr>
-        <p:style>
-          <a:lnRef idx="1">
-            <a:schemeClr val="accent1"/>
-          </a:lnRef>
-          <a:fillRef idx="3">
-            <a:schemeClr val="accent1"/>
-          </a:fillRef>
-          <a:effectRef idx="2">
-            <a:schemeClr val="accent1"/>
-          </a:effectRef>
-          <a:fontRef idx="minor">
-            <a:schemeClr val="lt1"/>
-          </a:fontRef>
-        </p:style>
-        <p:txBody>
-          <a:bodyPr rtlCol="0" anchor="ctr"/>
-          <a:lstStyle/>
-          <a:p>
-            <a:pPr algn="ctr"/>
-          </a:p>
-        </p:txBody>
-      </p:sp>
-      <p:sp>
-        <p:nvSpPr>
-          <p:cNvPr id="18" name="TextBox 17"/>
-          <p:cNvSpPr txBox="1"/>
-          <p:nvPr/>
-        </p:nvSpPr>
-        <p:spPr>
-          <a:xfrm>
-            <a:off x="9820656" y="1143000"/>
-            <a:ext cx="2084831" cy="1965960"/>
-          </a:xfrm>
-          <a:prstGeom prst="rect">
-            <a:avLst/>
-          </a:prstGeom>
-          <a:noFill/>
-        </p:spPr>
-        <p:txBody>
-          <a:bodyPr wrap="square" lIns="54864" rIns="54864" tIns="27432" bIns="18288">
-            <a:spAutoFit/>
-          </a:bodyPr>
-          <a:lstStyle/>
-          <a:p>
-            <a:pPr algn="l">
-              <a:spcBef>
-                <a:spcPts val="0"/>
-              </a:spcBef>
-              <a:spcAft>
-                <a:spcPts val="800"/>
-              </a:spcAft>
-            </a:pPr>
-            <a:r>
-              <a:rPr sz="1600" b="1" i="0">
-                <a:solidFill>
-                  <a:srgbClr val="1A7A6D"/>
-                </a:solidFill>
-                <a:latin typeface="Calibri"/>
-              </a:rPr>
-              <a:t>5  Collectives</a:t>
-            </a:r>
-          </a:p>
-          <a:p>
-            <a:pPr algn="l">
-              <a:spcBef>
-                <a:spcPts val="0"/>
-              </a:spcBef>
-              <a:spcAft>
-                <a:spcPts val="600"/>
-              </a:spcAft>
-            </a:pPr>
-            <a:r>
-              <a:rPr sz="1250" b="0" i="0">
-                <a:solidFill>
-                  <a:srgbClr val="1F2937"/>
-                </a:solidFill>
-                <a:latin typeface="Calibri"/>
-              </a:rPr>
-              <a:t>Tens of cells: jamming and neighbour alignment.</a:t>
-            </a:r>
-          </a:p>
-        </p:txBody>
-      </p:sp>
-      <p:sp>
-        <p:nvSpPr>
-          <p:cNvPr id="19" name="Rounded Rectangle 18"/>
-          <p:cNvSpPr/>
-          <p:nvPr/>
-        </p:nvSpPr>
-        <p:spPr>
-          <a:xfrm>
-            <a:off x="292608" y="3429000"/>
-            <a:ext cx="11594592" cy="2926080"/>
+            <a:off x="365760" y="5468112"/>
+            <a:ext cx="11430000" cy="960120"/>
           </a:xfrm>
           <a:prstGeom prst="roundRect">
             <a:avLst>
@@ -16445,14 +17366,14 @@
       </p:sp>
       <p:sp>
         <p:nvSpPr>
-          <p:cNvPr id="20" name="TextBox 19"/>
+          <p:cNvPr id="26" name="TextBox 25"/>
           <p:cNvSpPr txBox="1"/>
           <p:nvPr/>
         </p:nvSpPr>
         <p:spPr>
           <a:xfrm>
-            <a:off x="548640" y="3611880"/>
-            <a:ext cx="11109960" cy="2606040"/>
+            <a:off x="548640" y="5577840"/>
+            <a:ext cx="11064240" cy="777240"/>
           </a:xfrm>
           <a:prstGeom prst="rect">
             <a:avLst/>
@@ -16466,59 +17387,24 @@
           <a:lstStyle/>
           <a:p>
             <a:pPr algn="l">
+              <a:lnSpc>
+                <a:spcPct val="105000"/>
+              </a:lnSpc>
               <a:spcBef>
                 <a:spcPts val="0"/>
               </a:spcBef>
               <a:spcAft>
-                <a:spcPts val="1600"/>
+                <a:spcPts val="0"/>
               </a:spcAft>
             </a:pPr>
             <a:r>
-              <a:rPr sz="3200" b="1" i="0">
+              <a:rPr sz="1600" b="1" i="0">
                 <a:solidFill>
                   <a:srgbClr val="FFFFFF"/>
                 </a:solidFill>
                 <a:latin typeface="Calibri"/>
               </a:rPr>
-              <a:t>Thank you — Questions</a:t>
-            </a:r>
-          </a:p>
-          <a:p>
-            <a:pPr algn="l">
-              <a:spcBef>
-                <a:spcPts val="0"/>
-              </a:spcBef>
-              <a:spcAft>
-                <a:spcPts val="800"/>
-              </a:spcAft>
-            </a:pPr>
-            <a:r>
-              <a:rPr sz="1600" b="0" i="0">
-                <a:solidFill>
-                  <a:srgbClr val="FFFFFF"/>
-                </a:solidFill>
-                <a:latin typeface="Calibri"/>
-              </a:rPr>
-              <a:t>Siddharth Kumar  (2023PH10741)     ·     Soumik Roy  (2023PH10756)</a:t>
-            </a:r>
-          </a:p>
-          <a:p>
-            <a:pPr algn="l">
-              <a:spcBef>
-                <a:spcPts val="0"/>
-              </a:spcBef>
-              <a:spcAft>
-                <a:spcPts val="600"/>
-              </a:spcAft>
-            </a:pPr>
-            <a:r>
-              <a:rPr sz="1500" b="0" i="0">
-                <a:solidFill>
-                  <a:srgbClr val="C5D4DE"/>
-                </a:solidFill>
-                <a:latin typeface="Calibri"/>
-              </a:rPr>
-              <a:t>Adviser: Prof. Sujin B. Babu     ·     Department of Physics, IIT Delhi</a:t>
+              <a:t>Take-home: a verified local single-cell model now reproduces crawling without a global Stokes solve — providing a computational base for many-cell simulations.</a:t>
             </a:r>
           </a:p>
         </p:txBody>

</xml_diff>